<commit_message>
feat(slides): update fine-tuning slides
</commit_message>
<xml_diff>
--- a/slides/7-finetuning.pptx
+++ b/slides/7-finetuning.pptx
@@ -5,7 +5,7 @@
     <p:sldMasterId id="2147483660" r:id="rId1"/>
   </p:sldMasterIdLst>
   <p:notesMasterIdLst>
-    <p:notesMasterId r:id="rId22"/>
+    <p:notesMasterId r:id="rId20"/>
   </p:notesMasterIdLst>
   <p:sldIdLst>
     <p:sldId id="282" r:id="rId2"/>
@@ -15,19 +15,17 @@
     <p:sldId id="284" r:id="rId6"/>
     <p:sldId id="285" r:id="rId7"/>
     <p:sldId id="258" r:id="rId8"/>
-    <p:sldId id="260" r:id="rId9"/>
-    <p:sldId id="261" r:id="rId10"/>
-    <p:sldId id="262" r:id="rId11"/>
-    <p:sldId id="263" r:id="rId12"/>
-    <p:sldId id="264" r:id="rId13"/>
-    <p:sldId id="265" r:id="rId14"/>
-    <p:sldId id="286" r:id="rId15"/>
-    <p:sldId id="287" r:id="rId16"/>
-    <p:sldId id="288" r:id="rId17"/>
-    <p:sldId id="291" r:id="rId18"/>
-    <p:sldId id="289" r:id="rId19"/>
-    <p:sldId id="292" r:id="rId20"/>
-    <p:sldId id="293" r:id="rId21"/>
+    <p:sldId id="261" r:id="rId9"/>
+    <p:sldId id="262" r:id="rId10"/>
+    <p:sldId id="263" r:id="rId11"/>
+    <p:sldId id="264" r:id="rId12"/>
+    <p:sldId id="265" r:id="rId13"/>
+    <p:sldId id="286" r:id="rId14"/>
+    <p:sldId id="288" r:id="rId15"/>
+    <p:sldId id="291" r:id="rId16"/>
+    <p:sldId id="289" r:id="rId17"/>
+    <p:sldId id="292" r:id="rId18"/>
+    <p:sldId id="293" r:id="rId19"/>
   </p:sldIdLst>
   <p:sldSz cx="12192000" cy="6858000"/>
   <p:notesSz cx="6858000" cy="9144000"/>
@@ -1345,7 +1343,7 @@
           <a:p>
             <a:fld id="{9F0382AD-F4DE-5244-99F0-D1973462CD0B}" type="datetimeFigureOut">
               <a:rPr lang="en-US" smtClean="0"/>
-              <a:t>5/8/26</a:t>
+              <a:t>5/11/26</a:t>
             </a:fld>
             <a:endParaRPr lang="en-US"/>
           </a:p>
@@ -2118,7 +2116,7 @@
           <a:p>
             <a:fld id="{E8383924-A25F-B742-842B-F50923AECB75}" type="slidenum">
               <a:rPr lang="en-US" smtClean="0"/>
-              <a:t>14</a:t>
+              <a:t>13</a:t>
             </a:fld>
             <a:endParaRPr lang="en-US"/>
           </a:p>
@@ -2205,7 +2203,7 @@
           <a:p>
             <a:fld id="{E8383924-A25F-B742-842B-F50923AECB75}" type="slidenum">
               <a:rPr lang="en-US" smtClean="0"/>
-              <a:t>16</a:t>
+              <a:t>14</a:t>
             </a:fld>
             <a:endParaRPr lang="en-US"/>
           </a:p>
@@ -2355,7 +2353,7 @@
           <a:p>
             <a:fld id="{846CE7D5-CF57-46EF-B807-FDD0502418D4}" type="datetimeFigureOut">
               <a:rPr lang="en-GB" smtClean="0"/>
-              <a:t>08/05/2026</a:t>
+              <a:t>11/05/2026</a:t>
             </a:fld>
             <a:endParaRPr lang="en-GB"/>
           </a:p>
@@ -2525,7 +2523,7 @@
           <a:p>
             <a:fld id="{846CE7D5-CF57-46EF-B807-FDD0502418D4}" type="datetimeFigureOut">
               <a:rPr lang="en-GB" smtClean="0"/>
-              <a:t>08/05/2026</a:t>
+              <a:t>11/05/2026</a:t>
             </a:fld>
             <a:endParaRPr lang="en-GB"/>
           </a:p>
@@ -2705,7 +2703,7 @@
           <a:p>
             <a:fld id="{846CE7D5-CF57-46EF-B807-FDD0502418D4}" type="datetimeFigureOut">
               <a:rPr lang="en-GB" smtClean="0"/>
-              <a:t>08/05/2026</a:t>
+              <a:t>11/05/2026</a:t>
             </a:fld>
             <a:endParaRPr lang="en-GB"/>
           </a:p>
@@ -2875,7 +2873,7 @@
           <a:p>
             <a:fld id="{846CE7D5-CF57-46EF-B807-FDD0502418D4}" type="datetimeFigureOut">
               <a:rPr lang="en-GB" smtClean="0"/>
-              <a:t>08/05/2026</a:t>
+              <a:t>11/05/2026</a:t>
             </a:fld>
             <a:endParaRPr lang="en-GB"/>
           </a:p>
@@ -3121,7 +3119,7 @@
           <a:p>
             <a:fld id="{846CE7D5-CF57-46EF-B807-FDD0502418D4}" type="datetimeFigureOut">
               <a:rPr lang="en-GB" smtClean="0"/>
-              <a:t>08/05/2026</a:t>
+              <a:t>11/05/2026</a:t>
             </a:fld>
             <a:endParaRPr lang="en-GB"/>
           </a:p>
@@ -3353,7 +3351,7 @@
           <a:p>
             <a:fld id="{846CE7D5-CF57-46EF-B807-FDD0502418D4}" type="datetimeFigureOut">
               <a:rPr lang="en-GB" smtClean="0"/>
-              <a:t>08/05/2026</a:t>
+              <a:t>11/05/2026</a:t>
             </a:fld>
             <a:endParaRPr lang="en-GB"/>
           </a:p>
@@ -3720,7 +3718,7 @@
           <a:p>
             <a:fld id="{846CE7D5-CF57-46EF-B807-FDD0502418D4}" type="datetimeFigureOut">
               <a:rPr lang="en-GB" smtClean="0"/>
-              <a:t>08/05/2026</a:t>
+              <a:t>11/05/2026</a:t>
             </a:fld>
             <a:endParaRPr lang="en-GB"/>
           </a:p>
@@ -3838,7 +3836,7 @@
           <a:p>
             <a:fld id="{846CE7D5-CF57-46EF-B807-FDD0502418D4}" type="datetimeFigureOut">
               <a:rPr lang="en-GB" smtClean="0"/>
-              <a:t>08/05/2026</a:t>
+              <a:t>11/05/2026</a:t>
             </a:fld>
             <a:endParaRPr lang="en-GB"/>
           </a:p>
@@ -3933,7 +3931,7 @@
           <a:p>
             <a:fld id="{846CE7D5-CF57-46EF-B807-FDD0502418D4}" type="datetimeFigureOut">
               <a:rPr lang="en-GB" smtClean="0"/>
-              <a:t>08/05/2026</a:t>
+              <a:t>11/05/2026</a:t>
             </a:fld>
             <a:endParaRPr lang="en-GB"/>
           </a:p>
@@ -4210,7 +4208,7 @@
           <a:p>
             <a:fld id="{846CE7D5-CF57-46EF-B807-FDD0502418D4}" type="datetimeFigureOut">
               <a:rPr lang="en-GB" smtClean="0"/>
-              <a:t>08/05/2026</a:t>
+              <a:t>11/05/2026</a:t>
             </a:fld>
             <a:endParaRPr lang="en-GB"/>
           </a:p>
@@ -4467,7 +4465,7 @@
           <a:p>
             <a:fld id="{846CE7D5-CF57-46EF-B807-FDD0502418D4}" type="datetimeFigureOut">
               <a:rPr lang="en-GB" smtClean="0"/>
-              <a:t>08/05/2026</a:t>
+              <a:t>11/05/2026</a:t>
             </a:fld>
             <a:endParaRPr lang="en-GB"/>
           </a:p>
@@ -4680,7 +4678,7 @@
           <a:p>
             <a:fld id="{846CE7D5-CF57-46EF-B807-FDD0502418D4}" type="datetimeFigureOut">
               <a:rPr lang="en-GB" smtClean="0"/>
-              <a:t>08/05/2026</a:t>
+              <a:t>11/05/2026</a:t>
             </a:fld>
             <a:endParaRPr lang="en-GB"/>
           </a:p>
@@ -5352,1181 +5350,6 @@
   <p:cSld>
     <p:spTree>
       <p:nvGrpSpPr>
-        <p:cNvPr id="1" name="">
-          <a:extLst>
-            <a:ext uri="{FF2B5EF4-FFF2-40B4-BE49-F238E27FC236}">
-              <a16:creationId xmlns:a16="http://schemas.microsoft.com/office/drawing/2014/main" id="{09EDFC20-C59B-41D6-68AD-1540FFC43D98}"/>
-            </a:ext>
-          </a:extLst>
-        </p:cNvPr>
-        <p:cNvGrpSpPr/>
-        <p:nvPr/>
-      </p:nvGrpSpPr>
-      <p:grpSpPr>
-        <a:xfrm>
-          <a:off x="0" y="0"/>
-          <a:ext cx="0" cy="0"/>
-          <a:chOff x="0" y="0"/>
-          <a:chExt cx="0" cy="0"/>
-        </a:xfrm>
-      </p:grpSpPr>
-      <p:sp>
-        <p:nvSpPr>
-          <p:cNvPr id="2" name="Title 1">
-            <a:extLst>
-              <a:ext uri="{FF2B5EF4-FFF2-40B4-BE49-F238E27FC236}">
-                <a16:creationId xmlns:a16="http://schemas.microsoft.com/office/drawing/2014/main" id="{035EAA1E-A777-8CAB-4628-80086C03E001}"/>
-              </a:ext>
-            </a:extLst>
-          </p:cNvPr>
-          <p:cNvSpPr>
-            <a:spLocks noGrp="1"/>
-          </p:cNvSpPr>
-          <p:nvPr>
-            <p:ph type="title"/>
-          </p:nvPr>
-        </p:nvSpPr>
-        <p:spPr/>
-        <p:txBody>
-          <a:bodyPr/>
-          <a:lstStyle/>
-          <a:p>
-            <a:r>
-              <a:rPr lang="en-GB" dirty="0"/>
-              <a:t>Instruction tuning</a:t>
-            </a:r>
-            <a:endParaRPr lang="en-US" dirty="0"/>
-          </a:p>
-        </p:txBody>
-      </p:sp>
-      <p:sp>
-        <p:nvSpPr>
-          <p:cNvPr id="3" name="Content Placeholder 2">
-            <a:extLst>
-              <a:ext uri="{FF2B5EF4-FFF2-40B4-BE49-F238E27FC236}">
-                <a16:creationId xmlns:a16="http://schemas.microsoft.com/office/drawing/2014/main" id="{13F805AE-B7E0-24C4-B1B5-46870D07445A}"/>
-              </a:ext>
-            </a:extLst>
-          </p:cNvPr>
-          <p:cNvSpPr>
-            <a:spLocks noGrp="1"/>
-          </p:cNvSpPr>
-          <p:nvPr>
-            <p:ph idx="1"/>
-          </p:nvPr>
-        </p:nvSpPr>
-        <p:spPr/>
-        <p:txBody>
-          <a:bodyPr vert="horz" lIns="91440" tIns="45720" rIns="91440" bIns="45720" rtlCol="0" anchor="t">
-            <a:normAutofit/>
-          </a:bodyPr>
-          <a:lstStyle/>
-          <a:p>
-            <a:pPr marL="0" indent="0">
-              <a:lnSpc>
-                <a:spcPct val="114999"/>
-              </a:lnSpc>
-              <a:spcBef>
-                <a:spcPts val="0"/>
-              </a:spcBef>
-              <a:buNone/>
-            </a:pPr>
-            <a:r>
-              <a:rPr lang="en-GB" sz="1700" dirty="0">
-                <a:solidFill>
-                  <a:srgbClr val="666666"/>
-                </a:solidFill>
-                <a:latin typeface="Source Code Pro"/>
-                <a:ea typeface="Source Code Pro"/>
-              </a:rPr>
-              <a:t>&lt;|</a:t>
-            </a:r>
-            <a:r>
-              <a:rPr lang="en-GB" sz="1700" dirty="0" err="1">
-                <a:solidFill>
-                  <a:srgbClr val="666666"/>
-                </a:solidFill>
-                <a:latin typeface="Source Code Pro"/>
-                <a:ea typeface="Source Code Pro"/>
-              </a:rPr>
-              <a:t>begin_of_text</a:t>
-            </a:r>
-            <a:r>
-              <a:rPr lang="en-GB" sz="1700" dirty="0">
-                <a:solidFill>
-                  <a:srgbClr val="666666"/>
-                </a:solidFill>
-                <a:latin typeface="Source Code Pro"/>
-                <a:ea typeface="Source Code Pro"/>
-              </a:rPr>
-              <a:t>|&gt;&lt;|</a:t>
-            </a:r>
-            <a:r>
-              <a:rPr lang="en-GB" sz="1700" dirty="0" err="1">
-                <a:solidFill>
-                  <a:srgbClr val="666666"/>
-                </a:solidFill>
-                <a:latin typeface="Source Code Pro"/>
-                <a:ea typeface="Source Code Pro"/>
-              </a:rPr>
-              <a:t>start_header_id</a:t>
-            </a:r>
-            <a:r>
-              <a:rPr lang="en-GB" sz="1700" dirty="0">
-                <a:solidFill>
-                  <a:srgbClr val="666666"/>
-                </a:solidFill>
-                <a:latin typeface="Source Code Pro"/>
-                <a:ea typeface="Source Code Pro"/>
-              </a:rPr>
-              <a:t>|&gt;</a:t>
-            </a:r>
-            <a:r>
-              <a:rPr lang="en-GB" sz="1700" dirty="0">
-                <a:solidFill>
-                  <a:srgbClr val="0B7743"/>
-                </a:solidFill>
-                <a:latin typeface="Source Code Pro"/>
-                <a:ea typeface="Source Code Pro"/>
-              </a:rPr>
-              <a:t>system</a:t>
-            </a:r>
-            <a:r>
-              <a:rPr lang="en-GB" sz="1700" dirty="0">
-                <a:solidFill>
-                  <a:srgbClr val="666666"/>
-                </a:solidFill>
-                <a:latin typeface="Source Code Pro"/>
-                <a:ea typeface="Source Code Pro"/>
-              </a:rPr>
-              <a:t>&lt;|</a:t>
-            </a:r>
-            <a:r>
-              <a:rPr lang="en-GB" sz="1700" dirty="0" err="1">
-                <a:solidFill>
-                  <a:srgbClr val="666666"/>
-                </a:solidFill>
-                <a:latin typeface="Source Code Pro"/>
-                <a:ea typeface="Source Code Pro"/>
-              </a:rPr>
-              <a:t>end_header_id</a:t>
-            </a:r>
-            <a:r>
-              <a:rPr lang="en-GB" sz="1700" dirty="0">
-                <a:solidFill>
-                  <a:srgbClr val="666666"/>
-                </a:solidFill>
-                <a:latin typeface="Source Code Pro"/>
-                <a:ea typeface="Source Code Pro"/>
-              </a:rPr>
-              <a:t>|&gt;</a:t>
-            </a:r>
-            <a:endParaRPr lang="en-US" sz="1700" dirty="0">
-              <a:solidFill>
-                <a:srgbClr val="00FDC8"/>
-              </a:solidFill>
-              <a:latin typeface="Source Code Pro"/>
-              <a:ea typeface="Source Code Pro"/>
-            </a:endParaRPr>
-          </a:p>
-          <a:p>
-            <a:pPr marL="0" indent="0">
-              <a:lnSpc>
-                <a:spcPct val="114999"/>
-              </a:lnSpc>
-              <a:spcBef>
-                <a:spcPts val="1200"/>
-              </a:spcBef>
-              <a:buNone/>
-            </a:pPr>
-            <a:r>
-              <a:rPr lang="en-GB" sz="1700" dirty="0">
-                <a:solidFill>
-                  <a:srgbClr val="9325A5"/>
-                </a:solidFill>
-                <a:latin typeface="Source Code Pro"/>
-                <a:ea typeface="Source Code Pro"/>
-              </a:rPr>
-              <a:t>You are an expert in baking.</a:t>
-            </a:r>
-            <a:r>
-              <a:rPr lang="en-GB" sz="1700" dirty="0">
-                <a:solidFill>
-                  <a:srgbClr val="666666"/>
-                </a:solidFill>
-                <a:latin typeface="Source Code Pro"/>
-                <a:ea typeface="Source Code Pro"/>
-              </a:rPr>
-              <a:t>&lt;|</a:t>
-            </a:r>
-            <a:r>
-              <a:rPr lang="en-GB" sz="1700" dirty="0" err="1">
-                <a:solidFill>
-                  <a:srgbClr val="666666"/>
-                </a:solidFill>
-                <a:latin typeface="Source Code Pro"/>
-                <a:ea typeface="Source Code Pro"/>
-              </a:rPr>
-              <a:t>eot_id</a:t>
-            </a:r>
-            <a:r>
-              <a:rPr lang="en-GB" sz="1700" dirty="0">
-                <a:solidFill>
-                  <a:srgbClr val="666666"/>
-                </a:solidFill>
-                <a:latin typeface="Source Code Pro"/>
-                <a:ea typeface="Source Code Pro"/>
-              </a:rPr>
-              <a:t>|&gt;</a:t>
-            </a:r>
-            <a:endParaRPr lang="en-US" sz="1700" dirty="0">
-              <a:solidFill>
-                <a:srgbClr val="00FDC8"/>
-              </a:solidFill>
-              <a:latin typeface="Source Code Pro"/>
-              <a:ea typeface="Source Code Pro"/>
-            </a:endParaRPr>
-          </a:p>
-          <a:p>
-            <a:pPr marL="0" indent="0">
-              <a:lnSpc>
-                <a:spcPct val="114999"/>
-              </a:lnSpc>
-              <a:spcBef>
-                <a:spcPts val="1200"/>
-              </a:spcBef>
-              <a:buNone/>
-            </a:pPr>
-            <a:endParaRPr lang="en-GB" sz="1700" dirty="0">
-              <a:solidFill>
-                <a:srgbClr val="666666"/>
-              </a:solidFill>
-              <a:latin typeface="Source Code Pro"/>
-              <a:ea typeface="Source Code Pro"/>
-            </a:endParaRPr>
-          </a:p>
-          <a:p>
-            <a:pPr marL="0" indent="0">
-              <a:lnSpc>
-                <a:spcPct val="114999"/>
-              </a:lnSpc>
-              <a:spcBef>
-                <a:spcPts val="1200"/>
-              </a:spcBef>
-              <a:buNone/>
-            </a:pPr>
-            <a:r>
-              <a:rPr lang="en-GB" sz="1700" dirty="0">
-                <a:solidFill>
-                  <a:srgbClr val="666666"/>
-                </a:solidFill>
-                <a:latin typeface="Source Code Pro"/>
-                <a:ea typeface="Source Code Pro"/>
-              </a:rPr>
-              <a:t>&lt;|</a:t>
-            </a:r>
-            <a:r>
-              <a:rPr lang="en-GB" sz="1700" dirty="0" err="1">
-                <a:solidFill>
-                  <a:srgbClr val="666666"/>
-                </a:solidFill>
-                <a:latin typeface="Source Code Pro"/>
-                <a:ea typeface="Source Code Pro"/>
-              </a:rPr>
-              <a:t>start_header_id</a:t>
-            </a:r>
-            <a:r>
-              <a:rPr lang="en-GB" sz="1700" dirty="0">
-                <a:solidFill>
-                  <a:srgbClr val="666666"/>
-                </a:solidFill>
-                <a:latin typeface="Source Code Pro"/>
-                <a:ea typeface="Source Code Pro"/>
-              </a:rPr>
-              <a:t>|&gt;</a:t>
-            </a:r>
-            <a:r>
-              <a:rPr lang="en-GB" sz="1700" dirty="0">
-                <a:solidFill>
-                  <a:srgbClr val="0B7743"/>
-                </a:solidFill>
-                <a:latin typeface="Source Code Pro"/>
-                <a:ea typeface="Source Code Pro"/>
-              </a:rPr>
-              <a:t>user</a:t>
-            </a:r>
-            <a:r>
-              <a:rPr lang="en-GB" sz="1700" dirty="0">
-                <a:solidFill>
-                  <a:srgbClr val="666666"/>
-                </a:solidFill>
-                <a:latin typeface="Source Code Pro"/>
-                <a:ea typeface="Source Code Pro"/>
-              </a:rPr>
-              <a:t>&lt;|</a:t>
-            </a:r>
-            <a:r>
-              <a:rPr lang="en-GB" sz="1700" dirty="0" err="1">
-                <a:solidFill>
-                  <a:srgbClr val="666666"/>
-                </a:solidFill>
-                <a:latin typeface="Source Code Pro"/>
-                <a:ea typeface="Source Code Pro"/>
-              </a:rPr>
-              <a:t>end_header_id</a:t>
-            </a:r>
-            <a:r>
-              <a:rPr lang="en-GB" sz="1700" dirty="0">
-                <a:solidFill>
-                  <a:srgbClr val="666666"/>
-                </a:solidFill>
-                <a:latin typeface="Source Code Pro"/>
-                <a:ea typeface="Source Code Pro"/>
-              </a:rPr>
-              <a:t>|&gt;</a:t>
-            </a:r>
-            <a:endParaRPr lang="en-US" sz="1700" dirty="0">
-              <a:solidFill>
-                <a:srgbClr val="00FDC8"/>
-              </a:solidFill>
-              <a:latin typeface="Source Code Pro"/>
-              <a:ea typeface="Source Code Pro"/>
-            </a:endParaRPr>
-          </a:p>
-          <a:p>
-            <a:pPr marL="0" indent="0">
-              <a:lnSpc>
-                <a:spcPct val="114999"/>
-              </a:lnSpc>
-              <a:spcBef>
-                <a:spcPts val="1200"/>
-              </a:spcBef>
-              <a:buNone/>
-            </a:pPr>
-            <a:r>
-              <a:rPr lang="en-GB" sz="1700" dirty="0">
-                <a:solidFill>
-                  <a:srgbClr val="9325A5"/>
-                </a:solidFill>
-                <a:latin typeface="Source Code Pro"/>
-                <a:ea typeface="Source Code Pro"/>
-              </a:rPr>
-              <a:t>Provide me a recipe for macarons.</a:t>
-            </a:r>
-            <a:r>
-              <a:rPr lang="en-GB" sz="1700" dirty="0">
-                <a:solidFill>
-                  <a:srgbClr val="666666"/>
-                </a:solidFill>
-                <a:latin typeface="Source Code Pro"/>
-                <a:ea typeface="Source Code Pro"/>
-              </a:rPr>
-              <a:t>&lt;|</a:t>
-            </a:r>
-            <a:r>
-              <a:rPr lang="en-GB" sz="1700" err="1">
-                <a:solidFill>
-                  <a:srgbClr val="666666"/>
-                </a:solidFill>
-                <a:latin typeface="Source Code Pro"/>
-                <a:ea typeface="Source Code Pro"/>
-              </a:rPr>
-              <a:t>eot_id</a:t>
-            </a:r>
-            <a:r>
-              <a:rPr lang="en-GB" sz="1700" dirty="0">
-                <a:solidFill>
-                  <a:srgbClr val="666666"/>
-                </a:solidFill>
-                <a:latin typeface="Source Code Pro"/>
-                <a:ea typeface="Source Code Pro"/>
-              </a:rPr>
-              <a:t>|&gt;</a:t>
-            </a:r>
-            <a:endParaRPr lang="en-US" sz="1700" dirty="0">
-              <a:solidFill>
-                <a:srgbClr val="00FDC8"/>
-              </a:solidFill>
-              <a:latin typeface="Source Code Pro"/>
-              <a:ea typeface="Source Code Pro"/>
-            </a:endParaRPr>
-          </a:p>
-          <a:p>
-            <a:pPr marL="0" indent="0">
-              <a:lnSpc>
-                <a:spcPct val="114999"/>
-              </a:lnSpc>
-              <a:spcBef>
-                <a:spcPts val="1200"/>
-              </a:spcBef>
-              <a:buNone/>
-            </a:pPr>
-            <a:endParaRPr lang="en-GB" sz="1700" dirty="0">
-              <a:solidFill>
-                <a:srgbClr val="666666"/>
-              </a:solidFill>
-              <a:latin typeface="Source Code Pro"/>
-              <a:ea typeface="Source Code Pro"/>
-            </a:endParaRPr>
-          </a:p>
-          <a:p>
-            <a:pPr marL="0" indent="0">
-              <a:lnSpc>
-                <a:spcPct val="114999"/>
-              </a:lnSpc>
-              <a:spcBef>
-                <a:spcPts val="1200"/>
-              </a:spcBef>
-              <a:buNone/>
-            </a:pPr>
-            <a:r>
-              <a:rPr lang="en-GB" sz="1700" dirty="0">
-                <a:solidFill>
-                  <a:srgbClr val="666666"/>
-                </a:solidFill>
-                <a:latin typeface="Source Code Pro"/>
-                <a:ea typeface="Source Code Pro"/>
-              </a:rPr>
-              <a:t>&lt;|</a:t>
-            </a:r>
-            <a:r>
-              <a:rPr lang="en-GB" sz="1700" dirty="0" err="1">
-                <a:solidFill>
-                  <a:srgbClr val="666666"/>
-                </a:solidFill>
-                <a:latin typeface="Source Code Pro"/>
-                <a:ea typeface="Source Code Pro"/>
-              </a:rPr>
-              <a:t>start_header_id</a:t>
-            </a:r>
-            <a:r>
-              <a:rPr lang="en-GB" sz="1700" dirty="0">
-                <a:solidFill>
-                  <a:srgbClr val="666666"/>
-                </a:solidFill>
-                <a:latin typeface="Source Code Pro"/>
-                <a:ea typeface="Source Code Pro"/>
-              </a:rPr>
-              <a:t>|&gt;</a:t>
-            </a:r>
-            <a:r>
-              <a:rPr lang="en-GB" sz="1700" dirty="0">
-                <a:solidFill>
-                  <a:srgbClr val="0B7743"/>
-                </a:solidFill>
-                <a:latin typeface="Source Code Pro"/>
-                <a:ea typeface="Source Code Pro"/>
-              </a:rPr>
-              <a:t>assistant</a:t>
-            </a:r>
-            <a:r>
-              <a:rPr lang="en-GB" sz="1700" dirty="0">
-                <a:solidFill>
-                  <a:srgbClr val="666666"/>
-                </a:solidFill>
-                <a:latin typeface="Source Code Pro"/>
-                <a:ea typeface="Source Code Pro"/>
-              </a:rPr>
-              <a:t>&lt;|</a:t>
-            </a:r>
-            <a:r>
-              <a:rPr lang="en-GB" sz="1700" dirty="0" err="1">
-                <a:solidFill>
-                  <a:srgbClr val="666666"/>
-                </a:solidFill>
-                <a:latin typeface="Source Code Pro"/>
-                <a:ea typeface="Source Code Pro"/>
-              </a:rPr>
-              <a:t>end_header_id</a:t>
-            </a:r>
-            <a:r>
-              <a:rPr lang="en-GB" sz="1700" dirty="0">
-                <a:solidFill>
-                  <a:srgbClr val="666666"/>
-                </a:solidFill>
-                <a:latin typeface="Source Code Pro"/>
-                <a:ea typeface="Source Code Pro"/>
-              </a:rPr>
-              <a:t>|&gt;</a:t>
-            </a:r>
-            <a:endParaRPr lang="en-US" sz="1700" dirty="0">
-              <a:solidFill>
-                <a:srgbClr val="00FDC8"/>
-              </a:solidFill>
-              <a:latin typeface="Source Code Pro"/>
-              <a:ea typeface="Source Code Pro"/>
-            </a:endParaRPr>
-          </a:p>
-          <a:p>
-            <a:pPr marL="0" indent="0">
-              <a:lnSpc>
-                <a:spcPct val="114999"/>
-              </a:lnSpc>
-              <a:spcBef>
-                <a:spcPts val="1200"/>
-              </a:spcBef>
-              <a:spcAft>
-                <a:spcPts val="1200"/>
-              </a:spcAft>
-              <a:buNone/>
-            </a:pPr>
-            <a:r>
-              <a:rPr lang="en-GB" sz="1700" dirty="0">
-                <a:solidFill>
-                  <a:srgbClr val="9325A5"/>
-                </a:solidFill>
-                <a:latin typeface="Source Code Pro"/>
-                <a:ea typeface="Source Code Pro"/>
-              </a:rPr>
-              <a:t>Certainly! Here is a recipe for macarons …</a:t>
-            </a:r>
-            <a:r>
-              <a:rPr lang="en-GB" sz="1700" dirty="0">
-                <a:solidFill>
-                  <a:srgbClr val="666666"/>
-                </a:solidFill>
-                <a:latin typeface="Source Code Pro"/>
-                <a:ea typeface="Source Code Pro"/>
-              </a:rPr>
-              <a:t>&lt;|</a:t>
-            </a:r>
-            <a:r>
-              <a:rPr lang="en-GB" sz="1700" dirty="0" err="1">
-                <a:solidFill>
-                  <a:srgbClr val="666666"/>
-                </a:solidFill>
-                <a:latin typeface="Source Code Pro"/>
-                <a:ea typeface="Source Code Pro"/>
-              </a:rPr>
-              <a:t>eot_id</a:t>
-            </a:r>
-            <a:r>
-              <a:rPr lang="en-GB" sz="1700" dirty="0">
-                <a:solidFill>
-                  <a:srgbClr val="666666"/>
-                </a:solidFill>
-                <a:latin typeface="Source Code Pro"/>
-                <a:ea typeface="Source Code Pro"/>
-              </a:rPr>
-              <a:t>|&gt;</a:t>
-            </a:r>
-            <a:endParaRPr lang="en-GB" dirty="0"/>
-          </a:p>
-          <a:p>
-            <a:pPr marL="0" indent="0">
-              <a:buNone/>
-            </a:pPr>
-            <a:endParaRPr lang="en-GB" sz="900" dirty="0">
-              <a:latin typeface="IBM Plex Mono"/>
-            </a:endParaRPr>
-          </a:p>
-          <a:p>
-            <a:pPr marL="0" indent="0">
-              <a:buNone/>
-            </a:pPr>
-            <a:endParaRPr lang="en-GB" sz="900" dirty="0">
-              <a:latin typeface="IBM Plex Mono"/>
-            </a:endParaRPr>
-          </a:p>
-        </p:txBody>
-      </p:sp>
-      <p:sp>
-        <p:nvSpPr>
-          <p:cNvPr id="14" name="TextBox 13">
-            <a:extLst>
-              <a:ext uri="{FF2B5EF4-FFF2-40B4-BE49-F238E27FC236}">
-                <a16:creationId xmlns:a16="http://schemas.microsoft.com/office/drawing/2014/main" id="{7254B9F3-FEB3-C32D-B278-29497148BAD8}"/>
-              </a:ext>
-            </a:extLst>
-          </p:cNvPr>
-          <p:cNvSpPr txBox="1"/>
-          <p:nvPr/>
-        </p:nvSpPr>
-        <p:spPr>
-          <a:xfrm>
-            <a:off x="8643696" y="3294302"/>
-            <a:ext cx="1123759" cy="523220"/>
-          </a:xfrm>
-          <a:prstGeom prst="rect">
-            <a:avLst/>
-          </a:prstGeom>
-          <a:noFill/>
-        </p:spPr>
-        <p:txBody>
-          <a:bodyPr rot="0" spcFirstLastPara="0" vertOverflow="overflow" horzOverflow="overflow" vert="horz" wrap="square" lIns="91440" tIns="45720" rIns="91440" bIns="45720" numCol="1" spcCol="0" rtlCol="0" fromWordArt="0" anchor="t" anchorCtr="0" forceAA="0" compatLnSpc="1">
-            <a:prstTxWarp prst="textNoShape">
-              <a:avLst/>
-            </a:prstTxWarp>
-            <a:spAutoFit/>
-          </a:bodyPr>
-          <a:lstStyle/>
-          <a:p>
-            <a:r>
-              <a:rPr lang="en-GB" sz="2800" b="1" dirty="0">
-                <a:solidFill>
-                  <a:schemeClr val="accent3"/>
-                </a:solidFill>
-                <a:latin typeface="IBM Plex Mono"/>
-              </a:rPr>
-              <a:t>role</a:t>
-            </a:r>
-            <a:endParaRPr lang="en-US">
-              <a:solidFill>
-                <a:schemeClr val="accent3"/>
-              </a:solidFill>
-            </a:endParaRPr>
-          </a:p>
-        </p:txBody>
-      </p:sp>
-      <p:sp>
-        <p:nvSpPr>
-          <p:cNvPr id="16" name="Oval 15">
-            <a:extLst>
-              <a:ext uri="{FF2B5EF4-FFF2-40B4-BE49-F238E27FC236}">
-                <a16:creationId xmlns:a16="http://schemas.microsoft.com/office/drawing/2014/main" id="{839153F8-4457-6BD2-0D36-0896EABC4121}"/>
-              </a:ext>
-            </a:extLst>
-          </p:cNvPr>
-          <p:cNvSpPr/>
-          <p:nvPr/>
-        </p:nvSpPr>
-        <p:spPr>
-          <a:xfrm>
-            <a:off x="5441757" y="1762606"/>
-            <a:ext cx="1062181" cy="592666"/>
-          </a:xfrm>
-          <a:custGeom>
-            <a:avLst/>
-            <a:gdLst>
-              <a:gd name="csX0" fmla="*/ 0 w 1062181"/>
-              <a:gd name="csY0" fmla="*/ 296333 h 592666"/>
-              <a:gd name="csX1" fmla="*/ 531091 w 1062181"/>
-              <a:gd name="csY1" fmla="*/ 0 h 592666"/>
-              <a:gd name="csX2" fmla="*/ 1062182 w 1062181"/>
-              <a:gd name="csY2" fmla="*/ 296333 h 592666"/>
-              <a:gd name="csX3" fmla="*/ 531091 w 1062181"/>
-              <a:gd name="csY3" fmla="*/ 592666 h 592666"/>
-              <a:gd name="csX4" fmla="*/ 0 w 1062181"/>
-              <a:gd name="csY4" fmla="*/ 296333 h 592666"/>
-            </a:gdLst>
-            <a:ahLst/>
-            <a:cxnLst>
-              <a:cxn ang="0">
-                <a:pos x="csX0" y="csY0"/>
-              </a:cxn>
-              <a:cxn ang="0">
-                <a:pos x="csX1" y="csY1"/>
-              </a:cxn>
-              <a:cxn ang="0">
-                <a:pos x="csX2" y="csY2"/>
-              </a:cxn>
-              <a:cxn ang="0">
-                <a:pos x="csX3" y="csY3"/>
-              </a:cxn>
-              <a:cxn ang="0">
-                <a:pos x="csX4" y="csY4"/>
-              </a:cxn>
-            </a:cxnLst>
-            <a:rect l="l" t="t" r="r" b="b"/>
-            <a:pathLst>
-              <a:path w="1062181" h="592666" extrusionOk="0">
-                <a:moveTo>
-                  <a:pt x="0" y="296333"/>
-                </a:moveTo>
-                <a:cubicBezTo>
-                  <a:pt x="-7844" y="108050"/>
-                  <a:pt x="217113" y="1779"/>
-                  <a:pt x="531091" y="0"/>
-                </a:cubicBezTo>
-                <a:cubicBezTo>
-                  <a:pt x="815437" y="12492"/>
-                  <a:pt x="1041465" y="110896"/>
-                  <a:pt x="1062182" y="296333"/>
-                </a:cubicBezTo>
-                <a:cubicBezTo>
-                  <a:pt x="1075449" y="482420"/>
-                  <a:pt x="835636" y="595693"/>
-                  <a:pt x="531091" y="592666"/>
-                </a:cubicBezTo>
-                <a:cubicBezTo>
-                  <a:pt x="207623" y="613596"/>
-                  <a:pt x="-19889" y="442097"/>
-                  <a:pt x="0" y="296333"/>
-                </a:cubicBezTo>
-                <a:close/>
-              </a:path>
-            </a:pathLst>
-          </a:custGeom>
-          <a:noFill/>
-          <a:ln>
-            <a:solidFill>
-              <a:schemeClr val="accent3"/>
-            </a:solidFill>
-            <a:extLst>
-              <a:ext uri="{C807C97D-BFC1-408E-A445-0C87EB9F89A2}">
-                <ask:lineSketchStyleProps xmlns:ask="http://schemas.microsoft.com/office/drawing/2018/sketchyshapes" sd="3499211612">
-                  <a:prstGeom prst="ellipse">
-                    <a:avLst/>
-                  </a:prstGeom>
-                  <ask:type>
-                    <ask:lineSketchScribble/>
-                  </ask:type>
-                </ask:lineSketchStyleProps>
-              </a:ext>
-            </a:extLst>
-          </a:ln>
-        </p:spPr>
-        <p:style>
-          <a:lnRef idx="2">
-            <a:schemeClr val="accent1">
-              <a:shade val="15000"/>
-            </a:schemeClr>
-          </a:lnRef>
-          <a:fillRef idx="1">
-            <a:schemeClr val="accent1"/>
-          </a:fillRef>
-          <a:effectRef idx="0">
-            <a:schemeClr val="accent1"/>
-          </a:effectRef>
-          <a:fontRef idx="minor">
-            <a:schemeClr val="lt1"/>
-          </a:fontRef>
-        </p:style>
-        <p:txBody>
-          <a:bodyPr rtlCol="0" anchor="ctr"/>
-          <a:lstStyle/>
-          <a:p>
-            <a:pPr algn="ctr"/>
-            <a:endParaRPr lang="en-GB"/>
-          </a:p>
-        </p:txBody>
-      </p:sp>
-      <p:sp>
-        <p:nvSpPr>
-          <p:cNvPr id="18" name="Oval 17">
-            <a:extLst>
-              <a:ext uri="{FF2B5EF4-FFF2-40B4-BE49-F238E27FC236}">
-                <a16:creationId xmlns:a16="http://schemas.microsoft.com/office/drawing/2014/main" id="{F1B94677-CD84-1383-C609-6BCE2E13C11B}"/>
-              </a:ext>
-            </a:extLst>
-          </p:cNvPr>
-          <p:cNvSpPr/>
-          <p:nvPr/>
-        </p:nvSpPr>
-        <p:spPr>
-          <a:xfrm>
-            <a:off x="3300460" y="3161914"/>
-            <a:ext cx="754303" cy="469515"/>
-          </a:xfrm>
-          <a:custGeom>
-            <a:avLst/>
-            <a:gdLst>
-              <a:gd name="csX0" fmla="*/ 0 w 754303"/>
-              <a:gd name="csY0" fmla="*/ 234758 h 469515"/>
-              <a:gd name="csX1" fmla="*/ 377152 w 754303"/>
-              <a:gd name="csY1" fmla="*/ 0 h 469515"/>
-              <a:gd name="csX2" fmla="*/ 754304 w 754303"/>
-              <a:gd name="csY2" fmla="*/ 234758 h 469515"/>
-              <a:gd name="csX3" fmla="*/ 377152 w 754303"/>
-              <a:gd name="csY3" fmla="*/ 469516 h 469515"/>
-              <a:gd name="csX4" fmla="*/ 0 w 754303"/>
-              <a:gd name="csY4" fmla="*/ 234758 h 469515"/>
-            </a:gdLst>
-            <a:ahLst/>
-            <a:cxnLst>
-              <a:cxn ang="0">
-                <a:pos x="csX0" y="csY0"/>
-              </a:cxn>
-              <a:cxn ang="0">
-                <a:pos x="csX1" y="csY1"/>
-              </a:cxn>
-              <a:cxn ang="0">
-                <a:pos x="csX2" y="csY2"/>
-              </a:cxn>
-              <a:cxn ang="0">
-                <a:pos x="csX3" y="csY3"/>
-              </a:cxn>
-              <a:cxn ang="0">
-                <a:pos x="csX4" y="csY4"/>
-              </a:cxn>
-            </a:cxnLst>
-            <a:rect l="l" t="t" r="r" b="b"/>
-            <a:pathLst>
-              <a:path w="754303" h="469515" extrusionOk="0">
-                <a:moveTo>
-                  <a:pt x="0" y="234758"/>
-                </a:moveTo>
-                <a:cubicBezTo>
-                  <a:pt x="-16189" y="54286"/>
-                  <a:pt x="110711" y="5007"/>
-                  <a:pt x="377152" y="0"/>
-                </a:cubicBezTo>
-                <a:cubicBezTo>
-                  <a:pt x="575281" y="14162"/>
-                  <a:pt x="734498" y="84286"/>
-                  <a:pt x="754304" y="234758"/>
-                </a:cubicBezTo>
-                <a:cubicBezTo>
-                  <a:pt x="778862" y="405924"/>
-                  <a:pt x="620370" y="478929"/>
-                  <a:pt x="377152" y="469516"/>
-                </a:cubicBezTo>
-                <a:cubicBezTo>
-                  <a:pt x="154922" y="479188"/>
-                  <a:pt x="-24728" y="342161"/>
-                  <a:pt x="0" y="234758"/>
-                </a:cubicBezTo>
-                <a:close/>
-              </a:path>
-            </a:pathLst>
-          </a:custGeom>
-          <a:noFill/>
-          <a:ln>
-            <a:solidFill>
-              <a:schemeClr val="accent3"/>
-            </a:solidFill>
-            <a:extLst>
-              <a:ext uri="{C807C97D-BFC1-408E-A445-0C87EB9F89A2}">
-                <ask:lineSketchStyleProps xmlns:ask="http://schemas.microsoft.com/office/drawing/2018/sketchyshapes" sd="3499211612">
-                  <a:prstGeom prst="ellipse">
-                    <a:avLst/>
-                  </a:prstGeom>
-                  <ask:type>
-                    <ask:lineSketchScribble/>
-                  </ask:type>
-                </ask:lineSketchStyleProps>
-              </a:ext>
-            </a:extLst>
-          </a:ln>
-        </p:spPr>
-        <p:style>
-          <a:lnRef idx="2">
-            <a:schemeClr val="accent1">
-              <a:shade val="15000"/>
-            </a:schemeClr>
-          </a:lnRef>
-          <a:fillRef idx="1">
-            <a:schemeClr val="accent1"/>
-          </a:fillRef>
-          <a:effectRef idx="0">
-            <a:schemeClr val="accent1"/>
-          </a:effectRef>
-          <a:fontRef idx="minor">
-            <a:schemeClr val="lt1"/>
-          </a:fontRef>
-        </p:style>
-        <p:txBody>
-          <a:bodyPr rtlCol="0" anchor="ctr"/>
-          <a:lstStyle/>
-          <a:p>
-            <a:pPr algn="ctr"/>
-            <a:endParaRPr lang="en-GB"/>
-          </a:p>
-        </p:txBody>
-      </p:sp>
-      <p:sp>
-        <p:nvSpPr>
-          <p:cNvPr id="20" name="Oval 19">
-            <a:extLst>
-              <a:ext uri="{FF2B5EF4-FFF2-40B4-BE49-F238E27FC236}">
-                <a16:creationId xmlns:a16="http://schemas.microsoft.com/office/drawing/2014/main" id="{8807FB0B-1F99-27E8-0C2A-383CEA095050}"/>
-              </a:ext>
-            </a:extLst>
-          </p:cNvPr>
-          <p:cNvSpPr/>
-          <p:nvPr/>
-        </p:nvSpPr>
-        <p:spPr>
-          <a:xfrm>
-            <a:off x="3300460" y="4408824"/>
-            <a:ext cx="1293090" cy="592666"/>
-          </a:xfrm>
-          <a:custGeom>
-            <a:avLst/>
-            <a:gdLst>
-              <a:gd name="csX0" fmla="*/ 0 w 1293090"/>
-              <a:gd name="csY0" fmla="*/ 296333 h 592666"/>
-              <a:gd name="csX1" fmla="*/ 646545 w 1293090"/>
-              <a:gd name="csY1" fmla="*/ 0 h 592666"/>
-              <a:gd name="csX2" fmla="*/ 1293090 w 1293090"/>
-              <a:gd name="csY2" fmla="*/ 296333 h 592666"/>
-              <a:gd name="csX3" fmla="*/ 646545 w 1293090"/>
-              <a:gd name="csY3" fmla="*/ 592666 h 592666"/>
-              <a:gd name="csX4" fmla="*/ 0 w 1293090"/>
-              <a:gd name="csY4" fmla="*/ 296333 h 592666"/>
-            </a:gdLst>
-            <a:ahLst/>
-            <a:cxnLst>
-              <a:cxn ang="0">
-                <a:pos x="csX0" y="csY0"/>
-              </a:cxn>
-              <a:cxn ang="0">
-                <a:pos x="csX1" y="csY1"/>
-              </a:cxn>
-              <a:cxn ang="0">
-                <a:pos x="csX2" y="csY2"/>
-              </a:cxn>
-              <a:cxn ang="0">
-                <a:pos x="csX3" y="csY3"/>
-              </a:cxn>
-              <a:cxn ang="0">
-                <a:pos x="csX4" y="csY4"/>
-              </a:cxn>
-            </a:cxnLst>
-            <a:rect l="l" t="t" r="r" b="b"/>
-            <a:pathLst>
-              <a:path w="1293090" h="592666" extrusionOk="0">
-                <a:moveTo>
-                  <a:pt x="0" y="296333"/>
-                </a:moveTo>
-                <a:cubicBezTo>
-                  <a:pt x="-5973" y="113924"/>
-                  <a:pt x="267849" y="1861"/>
-                  <a:pt x="646545" y="0"/>
-                </a:cubicBezTo>
-                <a:cubicBezTo>
-                  <a:pt x="994655" y="12492"/>
-                  <a:pt x="1272373" y="110896"/>
-                  <a:pt x="1293090" y="296333"/>
-                </a:cubicBezTo>
-                <a:cubicBezTo>
-                  <a:pt x="1313348" y="494238"/>
-                  <a:pt x="1011811" y="594873"/>
-                  <a:pt x="646545" y="592666"/>
-                </a:cubicBezTo>
-                <a:cubicBezTo>
-                  <a:pt x="259313" y="613596"/>
-                  <a:pt x="-19889" y="442097"/>
-                  <a:pt x="0" y="296333"/>
-                </a:cubicBezTo>
-                <a:close/>
-              </a:path>
-            </a:pathLst>
-          </a:custGeom>
-          <a:noFill/>
-          <a:ln>
-            <a:solidFill>
-              <a:schemeClr val="accent3"/>
-            </a:solidFill>
-            <a:extLst>
-              <a:ext uri="{C807C97D-BFC1-408E-A445-0C87EB9F89A2}">
-                <ask:lineSketchStyleProps xmlns:ask="http://schemas.microsoft.com/office/drawing/2018/sketchyshapes" sd="3499211612">
-                  <a:prstGeom prst="ellipse">
-                    <a:avLst/>
-                  </a:prstGeom>
-                  <ask:type>
-                    <ask:lineSketchScribble/>
-                  </ask:type>
-                </ask:lineSketchStyleProps>
-              </a:ext>
-            </a:extLst>
-          </a:ln>
-        </p:spPr>
-        <p:style>
-          <a:lnRef idx="2">
-            <a:schemeClr val="accent1">
-              <a:shade val="15000"/>
-            </a:schemeClr>
-          </a:lnRef>
-          <a:fillRef idx="1">
-            <a:schemeClr val="accent1"/>
-          </a:fillRef>
-          <a:effectRef idx="0">
-            <a:schemeClr val="accent1"/>
-          </a:effectRef>
-          <a:fontRef idx="minor">
-            <a:schemeClr val="lt1"/>
-          </a:fontRef>
-        </p:style>
-        <p:txBody>
-          <a:bodyPr rtlCol="0" anchor="ctr"/>
-          <a:lstStyle/>
-          <a:p>
-            <a:pPr algn="ctr"/>
-            <a:endParaRPr lang="en-GB"/>
-          </a:p>
-        </p:txBody>
-      </p:sp>
-    </p:spTree>
-    <p:extLst>
-      <p:ext uri="{BB962C8B-B14F-4D97-AF65-F5344CB8AC3E}">
-        <p14:creationId xmlns:p14="http://schemas.microsoft.com/office/powerpoint/2010/main" val="1287061977"/>
-      </p:ext>
-    </p:extLst>
-  </p:cSld>
-  <p:clrMapOvr>
-    <a:masterClrMapping/>
-  </p:clrMapOvr>
-  <p:timing>
-    <p:tnLst>
-      <p:par>
-        <p:cTn id="1" dur="indefinite" restart="never" nodeType="tmRoot">
-          <p:childTnLst>
-            <p:seq concurrent="1" nextAc="seek">
-              <p:cTn id="2" dur="indefinite" nodeType="mainSeq">
-                <p:childTnLst>
-                  <p:par>
-                    <p:cTn id="3" fill="hold">
-                      <p:stCondLst>
-                        <p:cond delay="indefinite"/>
-                      </p:stCondLst>
-                      <p:childTnLst>
-                        <p:par>
-                          <p:cTn id="4" fill="hold">
-                            <p:stCondLst>
-                              <p:cond delay="0"/>
-                            </p:stCondLst>
-                            <p:childTnLst>
-                              <p:par>
-                                <p:cTn id="5" presetID="1" presetClass="entr" presetSubtype="0" fill="hold" grpId="0" nodeType="clickEffect">
-                                  <p:stCondLst>
-                                    <p:cond delay="0"/>
-                                  </p:stCondLst>
-                                  <p:childTnLst>
-                                    <p:set>
-                                      <p:cBhvr>
-                                        <p:cTn id="6" dur="1" fill="hold">
-                                          <p:stCondLst>
-                                            <p:cond delay="0"/>
-                                          </p:stCondLst>
-                                        </p:cTn>
-                                        <p:tgtEl>
-                                          <p:spTgt spid="14"/>
-                                        </p:tgtEl>
-                                        <p:attrNameLst>
-                                          <p:attrName>style.visibility</p:attrName>
-                                        </p:attrNameLst>
-                                      </p:cBhvr>
-                                      <p:to>
-                                        <p:strVal val="visible"/>
-                                      </p:to>
-                                    </p:set>
-                                  </p:childTnLst>
-                                </p:cTn>
-                              </p:par>
-                              <p:par>
-                                <p:cTn id="7" presetID="1" presetClass="entr" presetSubtype="0" fill="hold" grpId="0" nodeType="withEffect">
-                                  <p:stCondLst>
-                                    <p:cond delay="0"/>
-                                  </p:stCondLst>
-                                  <p:childTnLst>
-                                    <p:set>
-                                      <p:cBhvr>
-                                        <p:cTn id="8" dur="1" fill="hold">
-                                          <p:stCondLst>
-                                            <p:cond delay="0"/>
-                                          </p:stCondLst>
-                                        </p:cTn>
-                                        <p:tgtEl>
-                                          <p:spTgt spid="16"/>
-                                        </p:tgtEl>
-                                        <p:attrNameLst>
-                                          <p:attrName>style.visibility</p:attrName>
-                                        </p:attrNameLst>
-                                      </p:cBhvr>
-                                      <p:to>
-                                        <p:strVal val="visible"/>
-                                      </p:to>
-                                    </p:set>
-                                  </p:childTnLst>
-                                </p:cTn>
-                              </p:par>
-                              <p:par>
-                                <p:cTn id="9" presetID="1" presetClass="entr" presetSubtype="0" fill="hold" grpId="0" nodeType="withEffect">
-                                  <p:stCondLst>
-                                    <p:cond delay="0"/>
-                                  </p:stCondLst>
-                                  <p:childTnLst>
-                                    <p:set>
-                                      <p:cBhvr>
-                                        <p:cTn id="10" dur="1" fill="hold">
-                                          <p:stCondLst>
-                                            <p:cond delay="0"/>
-                                          </p:stCondLst>
-                                        </p:cTn>
-                                        <p:tgtEl>
-                                          <p:spTgt spid="18"/>
-                                        </p:tgtEl>
-                                        <p:attrNameLst>
-                                          <p:attrName>style.visibility</p:attrName>
-                                        </p:attrNameLst>
-                                      </p:cBhvr>
-                                      <p:to>
-                                        <p:strVal val="visible"/>
-                                      </p:to>
-                                    </p:set>
-                                  </p:childTnLst>
-                                </p:cTn>
-                              </p:par>
-                              <p:par>
-                                <p:cTn id="11" presetID="1" presetClass="entr" presetSubtype="0" fill="hold" grpId="0" nodeType="withEffect">
-                                  <p:stCondLst>
-                                    <p:cond delay="0"/>
-                                  </p:stCondLst>
-                                  <p:childTnLst>
-                                    <p:set>
-                                      <p:cBhvr>
-                                        <p:cTn id="12" dur="1" fill="hold">
-                                          <p:stCondLst>
-                                            <p:cond delay="0"/>
-                                          </p:stCondLst>
-                                        </p:cTn>
-                                        <p:tgtEl>
-                                          <p:spTgt spid="20"/>
-                                        </p:tgtEl>
-                                        <p:attrNameLst>
-                                          <p:attrName>style.visibility</p:attrName>
-                                        </p:attrNameLst>
-                                      </p:cBhvr>
-                                      <p:to>
-                                        <p:strVal val="visible"/>
-                                      </p:to>
-                                    </p:set>
-                                  </p:childTnLst>
-                                </p:cTn>
-                              </p:par>
-                            </p:childTnLst>
-                          </p:cTn>
-                        </p:par>
-                      </p:childTnLst>
-                    </p:cTn>
-                  </p:par>
-                </p:childTnLst>
-              </p:cTn>
-              <p:prevCondLst>
-                <p:cond evt="onPrev" delay="0">
-                  <p:tgtEl>
-                    <p:sldTgt/>
-                  </p:tgtEl>
-                </p:cond>
-              </p:prevCondLst>
-              <p:nextCondLst>
-                <p:cond evt="onNext" delay="0">
-                  <p:tgtEl>
-                    <p:sldTgt/>
-                  </p:tgtEl>
-                </p:cond>
-              </p:nextCondLst>
-            </p:seq>
-          </p:childTnLst>
-        </p:cTn>
-      </p:par>
-    </p:tnLst>
-    <p:bldLst>
-      <p:bldP spid="14" grpId="0"/>
-      <p:bldP spid="16" grpId="0" animBg="1"/>
-      <p:bldP spid="18" grpId="0" animBg="1"/>
-      <p:bldP spid="20" grpId="0" animBg="1"/>
-    </p:bldLst>
-  </p:timing>
-</p:sld>
-</file>
-
-<file path=ppt/slides/slide11.xml><?xml version="1.0" encoding="utf-8"?>
-<p:sld xmlns:a="http://schemas.openxmlformats.org/drawingml/2006/main" xmlns:r="http://schemas.openxmlformats.org/officeDocument/2006/relationships" xmlns:p="http://schemas.openxmlformats.org/presentationml/2006/main">
-  <p:cSld>
-    <p:spTree>
-      <p:nvGrpSpPr>
         <p:cNvPr id="1" name=""/>
         <p:cNvGrpSpPr/>
         <p:nvPr/>
@@ -6755,7 +5578,7 @@
 </p:sld>
 </file>
 
-<file path=ppt/slides/slide12.xml><?xml version="1.0" encoding="utf-8"?>
+<file path=ppt/slides/slide11.xml><?xml version="1.0" encoding="utf-8"?>
 <p:sld xmlns:a="http://schemas.openxmlformats.org/drawingml/2006/main" xmlns:r="http://schemas.openxmlformats.org/officeDocument/2006/relationships" xmlns:p="http://schemas.openxmlformats.org/presentationml/2006/main">
   <p:cSld>
     <p:spTree>
@@ -7631,7 +6454,7 @@
 </p:sld>
 </file>
 
-<file path=ppt/slides/slide13.xml><?xml version="1.0" encoding="utf-8"?>
+<file path=ppt/slides/slide12.xml><?xml version="1.0" encoding="utf-8"?>
 <p:sld xmlns:a="http://schemas.openxmlformats.org/drawingml/2006/main" xmlns:r="http://schemas.openxmlformats.org/officeDocument/2006/relationships" xmlns:p="http://schemas.openxmlformats.org/presentationml/2006/main">
   <p:cSld>
     <p:spTree>
@@ -7767,7 +6590,7 @@
 </p:sld>
 </file>
 
-<file path=ppt/slides/slide14.xml><?xml version="1.0" encoding="utf-8"?>
+<file path=ppt/slides/slide13.xml><?xml version="1.0" encoding="utf-8"?>
 <p:sld xmlns:a="http://schemas.openxmlformats.org/drawingml/2006/main" xmlns:r="http://schemas.openxmlformats.org/officeDocument/2006/relationships" xmlns:p="http://schemas.openxmlformats.org/presentationml/2006/main">
   <p:cSld>
     <p:spTree>
@@ -7817,8 +6640,8 @@
           </a:p>
         </p:txBody>
       </p:sp>
-      <mc:AlternateContent xmlns:mc="http://schemas.openxmlformats.org/markup-compatibility/2006">
-        <mc:Choice xmlns:a14="http://schemas.microsoft.com/office/drawing/2010/main" Requires="a14">
+      <mc:AlternateContent xmlns:mc="http://schemas.openxmlformats.org/markup-compatibility/2006" xmlns:a14="http://schemas.microsoft.com/office/drawing/2010/main">
+        <mc:Choice Requires="a14">
           <p:sp>
             <p:nvSpPr>
               <p:cNvPr id="5" name="Content Placeholder 2">
@@ -7940,7 +6763,7 @@
             </p:txBody>
           </p:sp>
         </mc:Choice>
-        <mc:Fallback>
+        <mc:Fallback xmlns="">
           <p:sp>
             <p:nvSpPr>
               <p:cNvPr id="5" name="Content Placeholder 2">
@@ -8027,67 +6850,7 @@
 </p:sld>
 </file>
 
-<file path=ppt/slides/slide15.xml><?xml version="1.0" encoding="utf-8"?>
-<p:sld xmlns:a="http://schemas.openxmlformats.org/drawingml/2006/main" xmlns:r="http://schemas.openxmlformats.org/officeDocument/2006/relationships" xmlns:p="http://schemas.openxmlformats.org/presentationml/2006/main">
-  <p:cSld>
-    <p:spTree>
-      <p:nvGrpSpPr>
-        <p:cNvPr id="1" name=""/>
-        <p:cNvGrpSpPr/>
-        <p:nvPr/>
-      </p:nvGrpSpPr>
-      <p:grpSpPr>
-        <a:xfrm>
-          <a:off x="0" y="0"/>
-          <a:ext cx="0" cy="0"/>
-          <a:chOff x="0" y="0"/>
-          <a:chExt cx="0" cy="0"/>
-        </a:xfrm>
-      </p:grpSpPr>
-      <p:pic>
-        <p:nvPicPr>
-          <p:cNvPr id="4" name="Picture 3">
-            <a:extLst>
-              <a:ext uri="{FF2B5EF4-FFF2-40B4-BE49-F238E27FC236}">
-                <a16:creationId xmlns:a16="http://schemas.microsoft.com/office/drawing/2014/main" id="{C0D2F02F-2B7C-D180-4B4D-1512FC6A9A17}"/>
-              </a:ext>
-            </a:extLst>
-          </p:cNvPr>
-          <p:cNvPicPr>
-            <a:picLocks noChangeAspect="1"/>
-          </p:cNvPicPr>
-          <p:nvPr/>
-        </p:nvPicPr>
-        <p:blipFill>
-          <a:blip r:embed="rId2"/>
-          <a:stretch>
-            <a:fillRect/>
-          </a:stretch>
-        </p:blipFill>
-        <p:spPr>
-          <a:xfrm>
-            <a:off x="1312333" y="1084573"/>
-            <a:ext cx="9567333" cy="4688854"/>
-          </a:xfrm>
-          <a:prstGeom prst="rect">
-            <a:avLst/>
-          </a:prstGeom>
-        </p:spPr>
-      </p:pic>
-    </p:spTree>
-    <p:extLst>
-      <p:ext uri="{BB962C8B-B14F-4D97-AF65-F5344CB8AC3E}">
-        <p14:creationId xmlns:p14="http://schemas.microsoft.com/office/powerpoint/2010/main" val="1241782244"/>
-      </p:ext>
-    </p:extLst>
-  </p:cSld>
-  <p:clrMapOvr>
-    <a:masterClrMapping/>
-  </p:clrMapOvr>
-</p:sld>
-</file>
-
-<file path=ppt/slides/slide16.xml><?xml version="1.0" encoding="utf-8"?>
+<file path=ppt/slides/slide14.xml><?xml version="1.0" encoding="utf-8"?>
 <p:sld xmlns:a="http://schemas.openxmlformats.org/drawingml/2006/main" xmlns:r="http://schemas.openxmlformats.org/officeDocument/2006/relationships" xmlns:p="http://schemas.openxmlformats.org/presentationml/2006/main">
   <p:cSld>
     <p:spTree>
@@ -8145,8 +6908,8 @@
           </a:p>
         </p:txBody>
       </p:sp>
-      <mc:AlternateContent xmlns:mc="http://schemas.openxmlformats.org/markup-compatibility/2006">
-        <mc:Choice xmlns:a14="http://schemas.microsoft.com/office/drawing/2010/main" Requires="a14">
+      <mc:AlternateContent xmlns:mc="http://schemas.openxmlformats.org/markup-compatibility/2006" xmlns:a14="http://schemas.microsoft.com/office/drawing/2010/main">
+        <mc:Choice Requires="a14">
           <p:sp>
             <p:nvSpPr>
               <p:cNvPr id="5" name="Content Placeholder 2">
@@ -8598,7 +7361,7 @@
             </p:txBody>
           </p:sp>
         </mc:Choice>
-        <mc:Fallback>
+        <mc:Fallback xmlns="">
           <p:sp>
             <p:nvSpPr>
               <p:cNvPr id="5" name="Content Placeholder 2">
@@ -9228,7 +7991,7 @@
 </p:sld>
 </file>
 
-<file path=ppt/slides/slide17.xml><?xml version="1.0" encoding="utf-8"?>
+<file path=ppt/slides/slide15.xml><?xml version="1.0" encoding="utf-8"?>
 <p:sld xmlns:a="http://schemas.openxmlformats.org/drawingml/2006/main" xmlns:r="http://schemas.openxmlformats.org/officeDocument/2006/relationships" xmlns:p="http://schemas.openxmlformats.org/presentationml/2006/main">
   <p:cSld>
     <p:spTree>
@@ -9292,8 +8055,8 @@
           </a:p>
         </p:txBody>
       </p:sp>
-      <mc:AlternateContent xmlns:mc="http://schemas.openxmlformats.org/markup-compatibility/2006">
-        <mc:Choice xmlns:a14="http://schemas.microsoft.com/office/drawing/2010/main" Requires="a14">
+      <mc:AlternateContent xmlns:mc="http://schemas.openxmlformats.org/markup-compatibility/2006" xmlns:a14="http://schemas.microsoft.com/office/drawing/2010/main">
+        <mc:Choice Requires="a14">
           <p:sp>
             <p:nvSpPr>
               <p:cNvPr id="5" name="Content Placeholder 2">
@@ -9511,7 +8274,7 @@
                 </a14:m>
                 <a:r>
                   <a:rPr lang="en-GB" b="0" dirty="0"/>
-                  <a:t> </a:t>
+                  <a:t> !</a:t>
                 </a:r>
               </a:p>
               <a:p>
@@ -9535,7 +8298,7 @@
             </p:txBody>
           </p:sp>
         </mc:Choice>
-        <mc:Fallback>
+        <mc:Fallback xmlns="">
           <p:sp>
             <p:nvSpPr>
               <p:cNvPr id="5" name="Content Placeholder 2">
@@ -9808,8 +8571,8 @@
           </a:p>
         </p:txBody>
       </p:sp>
-      <mc:AlternateContent xmlns:mc="http://schemas.openxmlformats.org/markup-compatibility/2006">
-        <mc:Choice xmlns:a14="http://schemas.microsoft.com/office/drawing/2010/main" Requires="a14">
+      <mc:AlternateContent xmlns:mc="http://schemas.openxmlformats.org/markup-compatibility/2006" xmlns:a14="http://schemas.microsoft.com/office/drawing/2010/main">
+        <mc:Choice Requires="a14">
           <p:sp>
             <p:nvSpPr>
               <p:cNvPr id="7" name="TextBox 6">
@@ -9838,6 +8601,7 @@
               </a:bodyPr>
               <a:lstStyle/>
               <a:p>
+                <a:pPr/>
                 <a14:m>
                   <m:oMathPara xmlns:m="http://schemas.openxmlformats.org/officeDocument/2006/math">
                     <m:oMathParaPr>
@@ -9880,7 +8644,13 @@
                                   <a:rPr lang="en-GB" sz="3600" b="0" i="1" smtClean="0">
                                     <a:latin typeface="Cambria Math" panose="02040503050406030204" pitchFamily="18" charset="0"/>
                                   </a:rPr>
-                                  <m:t>5.7</m:t>
+                                  <m:t>5</m:t>
+                                </m:r>
+                                <m:r>
+                                  <a:rPr lang="en-GB" sz="3600" b="0" i="1" smtClean="0">
+                                    <a:latin typeface="Cambria Math" panose="02040503050406030204" pitchFamily="18" charset="0"/>
+                                  </a:rPr>
+                                  <m:t>.7</m:t>
                                 </m:r>
                               </m:e>
                               <m:e>
@@ -10040,7 +8810,13 @@
                                   <a:rPr lang="en-GB" sz="3600" b="0" i="1" smtClean="0">
                                     <a:latin typeface="Cambria Math" panose="02040503050406030204" pitchFamily="18" charset="0"/>
                                   </a:rPr>
-                                  <m:t>4.2</m:t>
+                                  <m:t>4</m:t>
+                                </m:r>
+                                <m:r>
+                                  <a:rPr lang="en-GB" sz="3600" b="0" i="1" smtClean="0">
+                                    <a:latin typeface="Cambria Math" panose="02040503050406030204" pitchFamily="18" charset="0"/>
+                                  </a:rPr>
+                                  <m:t>.2</m:t>
                                 </m:r>
                               </m:e>
                               <m:e>
@@ -10126,7 +8902,7 @@
             </p:txBody>
           </p:sp>
         </mc:Choice>
-        <mc:Fallback>
+        <mc:Fallback xmlns="">
           <p:sp>
             <p:nvSpPr>
               <p:cNvPr id="7" name="TextBox 6">
@@ -10171,8 +8947,8 @@
           </p:sp>
         </mc:Fallback>
       </mc:AlternateContent>
-      <mc:AlternateContent xmlns:mc="http://schemas.openxmlformats.org/markup-compatibility/2006">
-        <mc:Choice xmlns:a14="http://schemas.microsoft.com/office/drawing/2010/main" Requires="a14">
+      <mc:AlternateContent xmlns:mc="http://schemas.openxmlformats.org/markup-compatibility/2006" xmlns:a14="http://schemas.microsoft.com/office/drawing/2010/main">
+        <mc:Choice Requires="a14">
           <p:sp>
             <p:nvSpPr>
               <p:cNvPr id="10" name="TextBox 9">
@@ -10201,6 +8977,7 @@
               </a:bodyPr>
               <a:lstStyle/>
               <a:p>
+                <a:pPr/>
                 <a14:m>
                   <m:oMathPara xmlns:m="http://schemas.openxmlformats.org/officeDocument/2006/math">
                     <m:oMathParaPr>
@@ -10280,7 +9057,7 @@
             </p:txBody>
           </p:sp>
         </mc:Choice>
-        <mc:Fallback>
+        <mc:Fallback xmlns="">
           <p:sp>
             <p:nvSpPr>
               <p:cNvPr id="10" name="TextBox 9">
@@ -10325,8 +9102,8 @@
           </p:sp>
         </mc:Fallback>
       </mc:AlternateContent>
-      <mc:AlternateContent xmlns:mc="http://schemas.openxmlformats.org/markup-compatibility/2006">
-        <mc:Choice xmlns:a14="http://schemas.microsoft.com/office/drawing/2010/main" Requires="a14">
+      <mc:AlternateContent xmlns:mc="http://schemas.openxmlformats.org/markup-compatibility/2006" xmlns:a14="http://schemas.microsoft.com/office/drawing/2010/main">
+        <mc:Choice Requires="a14">
           <p:sp>
             <p:nvSpPr>
               <p:cNvPr id="11" name="TextBox 10">
@@ -10355,6 +9132,7 @@
               </a:bodyPr>
               <a:lstStyle/>
               <a:p>
+                <a:pPr/>
                 <a14:m>
                   <m:oMathPara xmlns:m="http://schemas.openxmlformats.org/officeDocument/2006/math">
                     <m:oMathParaPr>
@@ -10443,7 +9221,7 @@
             </p:txBody>
           </p:sp>
         </mc:Choice>
-        <mc:Fallback>
+        <mc:Fallback xmlns="">
           <p:sp>
             <p:nvSpPr>
               <p:cNvPr id="11" name="TextBox 10">
@@ -10501,7 +9279,7 @@
 </p:sld>
 </file>
 
-<file path=ppt/slides/slide18.xml><?xml version="1.0" encoding="utf-8"?>
+<file path=ppt/slides/slide16.xml><?xml version="1.0" encoding="utf-8"?>
 <p:sld xmlns:a="http://schemas.openxmlformats.org/drawingml/2006/main" xmlns:r="http://schemas.openxmlformats.org/officeDocument/2006/relationships" xmlns:p="http://schemas.openxmlformats.org/presentationml/2006/main">
   <p:cSld>
     <p:spTree>
@@ -10559,8 +9337,8 @@
           </a:p>
         </p:txBody>
       </p:sp>
-      <mc:AlternateContent xmlns:mc="http://schemas.openxmlformats.org/markup-compatibility/2006">
-        <mc:Choice xmlns:a14="http://schemas.microsoft.com/office/drawing/2010/main" Requires="a14">
+      <mc:AlternateContent xmlns:mc="http://schemas.openxmlformats.org/markup-compatibility/2006" xmlns:a14="http://schemas.microsoft.com/office/drawing/2010/main">
+        <mc:Choice Requires="a14">
           <p:sp>
             <p:nvSpPr>
               <p:cNvPr id="5" name="Content Placeholder 2">
@@ -10651,7 +9429,7 @@
             </p:txBody>
           </p:sp>
         </mc:Choice>
-        <mc:Fallback>
+        <mc:Fallback xmlns="">
           <p:sp>
             <p:nvSpPr>
               <p:cNvPr id="5" name="Content Placeholder 2">
@@ -10924,8 +9702,8 @@
           </a:p>
         </p:txBody>
       </p:sp>
-      <mc:AlternateContent xmlns:mc="http://schemas.openxmlformats.org/markup-compatibility/2006">
-        <mc:Choice xmlns:a14="http://schemas.microsoft.com/office/drawing/2010/main" Requires="a14">
+      <mc:AlternateContent xmlns:mc="http://schemas.openxmlformats.org/markup-compatibility/2006" xmlns:a14="http://schemas.microsoft.com/office/drawing/2010/main">
+        <mc:Choice Requires="a14">
           <p:sp>
             <p:nvSpPr>
               <p:cNvPr id="12" name="Rectangle 11">
@@ -11065,7 +9843,7 @@
             </p:txBody>
           </p:sp>
         </mc:Choice>
-        <mc:Fallback>
+        <mc:Fallback xmlns="">
           <p:sp>
             <p:nvSpPr>
               <p:cNvPr id="12" name="Rectangle 11">
@@ -11115,8 +9893,8 @@
           </p:sp>
         </mc:Fallback>
       </mc:AlternateContent>
-      <mc:AlternateContent xmlns:mc="http://schemas.openxmlformats.org/markup-compatibility/2006">
-        <mc:Choice xmlns:a14="http://schemas.microsoft.com/office/drawing/2010/main" Requires="a14">
+      <mc:AlternateContent xmlns:mc="http://schemas.openxmlformats.org/markup-compatibility/2006" xmlns:a14="http://schemas.microsoft.com/office/drawing/2010/main">
+        <mc:Choice Requires="a14">
           <p:sp>
             <p:nvSpPr>
               <p:cNvPr id="13" name="Rectangle 12">
@@ -11262,7 +10040,7 @@
             </p:txBody>
           </p:sp>
         </mc:Choice>
-        <mc:Fallback>
+        <mc:Fallback xmlns="">
           <p:sp>
             <p:nvSpPr>
               <p:cNvPr id="13" name="Rectangle 12">
@@ -11312,8 +10090,8 @@
           </p:sp>
         </mc:Fallback>
       </mc:AlternateContent>
-      <mc:AlternateContent xmlns:mc="http://schemas.openxmlformats.org/markup-compatibility/2006">
-        <mc:Choice xmlns:a14="http://schemas.microsoft.com/office/drawing/2010/main" Requires="a14">
+      <mc:AlternateContent xmlns:mc="http://schemas.openxmlformats.org/markup-compatibility/2006" xmlns:a14="http://schemas.microsoft.com/office/drawing/2010/main">
+        <mc:Choice Requires="a14">
           <p:sp>
             <p:nvSpPr>
               <p:cNvPr id="14" name="Rectangle 13">
@@ -11451,7 +10229,7 @@
             </p:txBody>
           </p:sp>
         </mc:Choice>
-        <mc:Fallback>
+        <mc:Fallback xmlns="">
           <p:sp>
             <p:nvSpPr>
               <p:cNvPr id="14" name="Rectangle 13">
@@ -11501,8 +10279,8 @@
           </p:sp>
         </mc:Fallback>
       </mc:AlternateContent>
-      <mc:AlternateContent xmlns:mc="http://schemas.openxmlformats.org/markup-compatibility/2006">
-        <mc:Choice xmlns:a14="http://schemas.microsoft.com/office/drawing/2010/main" Requires="a14">
+      <mc:AlternateContent xmlns:mc="http://schemas.openxmlformats.org/markup-compatibility/2006" xmlns:a14="http://schemas.microsoft.com/office/drawing/2010/main">
+        <mc:Choice Requires="a14">
           <p:sp>
             <p:nvSpPr>
               <p:cNvPr id="15" name="TextBox 14">
@@ -11531,6 +10309,7 @@
               </a:bodyPr>
               <a:lstStyle/>
               <a:p>
+                <a:pPr/>
                 <a14:m>
                   <m:oMathPara xmlns:m="http://schemas.openxmlformats.org/officeDocument/2006/math">
                     <m:oMathParaPr>
@@ -11551,7 +10330,7 @@
             </p:txBody>
           </p:sp>
         </mc:Choice>
-        <mc:Fallback>
+        <mc:Fallback xmlns="">
           <p:sp>
             <p:nvSpPr>
               <p:cNvPr id="15" name="TextBox 14">
@@ -11596,8 +10375,8 @@
           </p:sp>
         </mc:Fallback>
       </mc:AlternateContent>
-      <mc:AlternateContent xmlns:mc="http://schemas.openxmlformats.org/markup-compatibility/2006">
-        <mc:Choice xmlns:a14="http://schemas.microsoft.com/office/drawing/2010/main" Requires="a14">
+      <mc:AlternateContent xmlns:mc="http://schemas.openxmlformats.org/markup-compatibility/2006" xmlns:a14="http://schemas.microsoft.com/office/drawing/2010/main">
+        <mc:Choice Requires="a14">
           <p:sp>
             <p:nvSpPr>
               <p:cNvPr id="16" name="TextBox 15">
@@ -11626,6 +10405,7 @@
               </a:bodyPr>
               <a:lstStyle/>
               <a:p>
+                <a:pPr/>
                 <a14:m>
                   <m:oMathPara xmlns:m="http://schemas.openxmlformats.org/officeDocument/2006/math">
                     <m:oMathParaPr>
@@ -11649,7 +10429,7 @@
             </p:txBody>
           </p:sp>
         </mc:Choice>
-        <mc:Fallback>
+        <mc:Fallback xmlns="">
           <p:sp>
             <p:nvSpPr>
               <p:cNvPr id="16" name="TextBox 15">
@@ -11998,8 +10778,8 @@
           </a:p>
         </p:txBody>
       </p:sp>
-      <mc:AlternateContent xmlns:mc="http://schemas.openxmlformats.org/markup-compatibility/2006">
-        <mc:Choice xmlns:a14="http://schemas.microsoft.com/office/drawing/2010/main" Requires="a14">
+      <mc:AlternateContent xmlns:mc="http://schemas.openxmlformats.org/markup-compatibility/2006" xmlns:a14="http://schemas.microsoft.com/office/drawing/2010/main">
+        <mc:Choice Requires="a14">
           <p:sp>
             <p:nvSpPr>
               <p:cNvPr id="29" name="TextBox 28">
@@ -12094,7 +10874,7 @@
             </p:txBody>
           </p:sp>
         </mc:Choice>
-        <mc:Fallback>
+        <mc:Fallback xmlns="">
           <p:sp>
             <p:nvSpPr>
               <p:cNvPr id="29" name="TextBox 28">
@@ -12330,7 +11110,7 @@
 </p:sld>
 </file>
 
-<file path=ppt/slides/slide19.xml><?xml version="1.0" encoding="utf-8"?>
+<file path=ppt/slides/slide17.xml><?xml version="1.0" encoding="utf-8"?>
 <p:sld xmlns:a="http://schemas.openxmlformats.org/drawingml/2006/main" xmlns:r="http://schemas.openxmlformats.org/officeDocument/2006/relationships" xmlns:p="http://schemas.openxmlformats.org/presentationml/2006/main">
   <p:cSld>
     <p:spTree>
@@ -12388,8 +11168,8 @@
           </a:p>
         </p:txBody>
       </p:sp>
-      <mc:AlternateContent xmlns:mc="http://schemas.openxmlformats.org/markup-compatibility/2006">
-        <mc:Choice xmlns:a14="http://schemas.microsoft.com/office/drawing/2010/main" Requires="a14">
+      <mc:AlternateContent xmlns:mc="http://schemas.openxmlformats.org/markup-compatibility/2006" xmlns:a14="http://schemas.microsoft.com/office/drawing/2010/main">
+        <mc:Choice Requires="a14">
           <p:sp>
             <p:nvSpPr>
               <p:cNvPr id="5" name="Content Placeholder 2">
@@ -12542,7 +11322,7 @@
             </p:txBody>
           </p:sp>
         </mc:Choice>
-        <mc:Fallback>
+        <mc:Fallback xmlns="">
           <p:sp>
             <p:nvSpPr>
               <p:cNvPr id="5" name="Content Placeholder 2">
@@ -12620,6 +11400,334 @@
     <p:extLst>
       <p:ext uri="{BB962C8B-B14F-4D97-AF65-F5344CB8AC3E}">
         <p14:creationId xmlns:p14="http://schemas.microsoft.com/office/powerpoint/2010/main" val="1844177037"/>
+      </p:ext>
+    </p:extLst>
+  </p:cSld>
+  <p:clrMapOvr>
+    <a:masterClrMapping/>
+  </p:clrMapOvr>
+</p:sld>
+</file>
+
+<file path=ppt/slides/slide18.xml><?xml version="1.0" encoding="utf-8"?>
+<p:sld xmlns:a="http://schemas.openxmlformats.org/drawingml/2006/main" xmlns:r="http://schemas.openxmlformats.org/officeDocument/2006/relationships" xmlns:p="http://schemas.openxmlformats.org/presentationml/2006/main">
+  <p:cSld>
+    <p:spTree>
+      <p:nvGrpSpPr>
+        <p:cNvPr id="1" name=""/>
+        <p:cNvGrpSpPr/>
+        <p:nvPr/>
+      </p:nvGrpSpPr>
+      <p:grpSpPr>
+        <a:xfrm>
+          <a:off x="0" y="0"/>
+          <a:ext cx="0" cy="0"/>
+          <a:chOff x="0" y="0"/>
+          <a:chExt cx="0" cy="0"/>
+        </a:xfrm>
+      </p:grpSpPr>
+      <p:sp>
+        <p:nvSpPr>
+          <p:cNvPr id="4" name="Title 1">
+            <a:extLst>
+              <a:ext uri="{FF2B5EF4-FFF2-40B4-BE49-F238E27FC236}">
+                <a16:creationId xmlns:a16="http://schemas.microsoft.com/office/drawing/2014/main" id="{DF00D04C-A321-D685-8023-6DC42CB3EA55}"/>
+              </a:ext>
+            </a:extLst>
+          </p:cNvPr>
+          <p:cNvSpPr>
+            <a:spLocks noGrp="1"/>
+          </p:cNvSpPr>
+          <p:nvPr>
+            <p:ph type="title"/>
+          </p:nvPr>
+        </p:nvSpPr>
+        <p:spPr>
+          <a:xfrm>
+            <a:off x="838199" y="365125"/>
+            <a:ext cx="10790583" cy="1325563"/>
+          </a:xfrm>
+        </p:spPr>
+        <p:txBody>
+          <a:bodyPr/>
+          <a:lstStyle/>
+          <a:p>
+            <a:r>
+              <a:rPr lang="en-US" dirty="0"/>
+              <a:t>Quantized Low Rank Adaptation (</a:t>
+            </a:r>
+            <a:r>
+              <a:rPr lang="en-US" dirty="0" err="1"/>
+              <a:t>qLoRA</a:t>
+            </a:r>
+            <a:r>
+              <a:rPr lang="en-US" dirty="0"/>
+              <a:t>)</a:t>
+            </a:r>
+          </a:p>
+        </p:txBody>
+      </p:sp>
+      <p:pic>
+        <p:nvPicPr>
+          <p:cNvPr id="5" name="Picture 4">
+            <a:extLst>
+              <a:ext uri="{FF2B5EF4-FFF2-40B4-BE49-F238E27FC236}">
+                <a16:creationId xmlns:a16="http://schemas.microsoft.com/office/drawing/2014/main" id="{2027358D-2B46-8E48-4FB6-D4A9B320DC2A}"/>
+              </a:ext>
+            </a:extLst>
+          </p:cNvPr>
+          <p:cNvPicPr>
+            <a:picLocks noChangeAspect="1"/>
+          </p:cNvPicPr>
+          <p:nvPr/>
+        </p:nvPicPr>
+        <p:blipFill>
+          <a:blip r:embed="rId2"/>
+          <a:stretch>
+            <a:fillRect/>
+          </a:stretch>
+        </p:blipFill>
+        <p:spPr>
+          <a:xfrm>
+            <a:off x="2209800" y="2282085"/>
+            <a:ext cx="7772400" cy="2949814"/>
+          </a:xfrm>
+          <a:prstGeom prst="rect">
+            <a:avLst/>
+          </a:prstGeom>
+        </p:spPr>
+      </p:pic>
+      <p:sp>
+        <p:nvSpPr>
+          <p:cNvPr id="6" name="Content Placeholder 2">
+            <a:extLst>
+              <a:ext uri="{FF2B5EF4-FFF2-40B4-BE49-F238E27FC236}">
+                <a16:creationId xmlns:a16="http://schemas.microsoft.com/office/drawing/2014/main" id="{FA5E7CB3-008B-3B87-BE55-E3D113772078}"/>
+              </a:ext>
+            </a:extLst>
+          </p:cNvPr>
+          <p:cNvSpPr txBox="1">
+            <a:spLocks/>
+          </p:cNvSpPr>
+          <p:nvPr/>
+        </p:nvSpPr>
+        <p:spPr>
+          <a:xfrm>
+            <a:off x="9253420" y="6136205"/>
+            <a:ext cx="3118738" cy="529390"/>
+          </a:xfrm>
+          <a:prstGeom prst="rect">
+            <a:avLst/>
+          </a:prstGeom>
+        </p:spPr>
+        <p:txBody>
+          <a:bodyPr vert="horz" lIns="91440" tIns="45720" rIns="91440" bIns="45720" rtlCol="0">
+            <a:normAutofit/>
+          </a:bodyPr>
+          <a:lstStyle>
+            <a:lvl1pPr marL="228600" indent="-228600" algn="l" defTabSz="914400" rtl="0" eaLnBrk="1" latinLnBrk="0" hangingPunct="1">
+              <a:lnSpc>
+                <a:spcPct val="90000"/>
+              </a:lnSpc>
+              <a:spcBef>
+                <a:spcPts val="1000"/>
+              </a:spcBef>
+              <a:buFont typeface="Arial" panose="020B0604020202020204" pitchFamily="34" charset="0"/>
+              <a:buChar char="•"/>
+              <a:defRPr sz="2800" kern="1200">
+                <a:solidFill>
+                  <a:schemeClr val="tx1"/>
+                </a:solidFill>
+                <a:latin typeface="+mn-lt"/>
+                <a:ea typeface="+mn-ea"/>
+                <a:cs typeface="+mn-cs"/>
+              </a:defRPr>
+            </a:lvl1pPr>
+            <a:lvl2pPr marL="685800" indent="-228600" algn="l" defTabSz="914400" rtl="0" eaLnBrk="1" latinLnBrk="0" hangingPunct="1">
+              <a:lnSpc>
+                <a:spcPct val="90000"/>
+              </a:lnSpc>
+              <a:spcBef>
+                <a:spcPts val="500"/>
+              </a:spcBef>
+              <a:buFont typeface="Arial" panose="020B0604020202020204" pitchFamily="34" charset="0"/>
+              <a:buChar char="•"/>
+              <a:defRPr sz="2400" kern="1200">
+                <a:solidFill>
+                  <a:schemeClr val="tx1"/>
+                </a:solidFill>
+                <a:latin typeface="+mn-lt"/>
+                <a:ea typeface="+mn-ea"/>
+                <a:cs typeface="+mn-cs"/>
+              </a:defRPr>
+            </a:lvl2pPr>
+            <a:lvl3pPr marL="1143000" indent="-228600" algn="l" defTabSz="914400" rtl="0" eaLnBrk="1" latinLnBrk="0" hangingPunct="1">
+              <a:lnSpc>
+                <a:spcPct val="90000"/>
+              </a:lnSpc>
+              <a:spcBef>
+                <a:spcPts val="500"/>
+              </a:spcBef>
+              <a:buFont typeface="Arial" panose="020B0604020202020204" pitchFamily="34" charset="0"/>
+              <a:buChar char="•"/>
+              <a:defRPr sz="2000" kern="1200">
+                <a:solidFill>
+                  <a:schemeClr val="tx1"/>
+                </a:solidFill>
+                <a:latin typeface="+mn-lt"/>
+                <a:ea typeface="+mn-ea"/>
+                <a:cs typeface="+mn-cs"/>
+              </a:defRPr>
+            </a:lvl3pPr>
+            <a:lvl4pPr marL="1600200" indent="-228600" algn="l" defTabSz="914400" rtl="0" eaLnBrk="1" latinLnBrk="0" hangingPunct="1">
+              <a:lnSpc>
+                <a:spcPct val="90000"/>
+              </a:lnSpc>
+              <a:spcBef>
+                <a:spcPts val="500"/>
+              </a:spcBef>
+              <a:buFont typeface="Arial" panose="020B0604020202020204" pitchFamily="34" charset="0"/>
+              <a:buChar char="•"/>
+              <a:defRPr sz="1800" kern="1200">
+                <a:solidFill>
+                  <a:schemeClr val="tx1"/>
+                </a:solidFill>
+                <a:latin typeface="+mn-lt"/>
+                <a:ea typeface="+mn-ea"/>
+                <a:cs typeface="+mn-cs"/>
+              </a:defRPr>
+            </a:lvl4pPr>
+            <a:lvl5pPr marL="2057400" indent="-228600" algn="l" defTabSz="914400" rtl="0" eaLnBrk="1" latinLnBrk="0" hangingPunct="1">
+              <a:lnSpc>
+                <a:spcPct val="90000"/>
+              </a:lnSpc>
+              <a:spcBef>
+                <a:spcPts val="500"/>
+              </a:spcBef>
+              <a:buFont typeface="Arial" panose="020B0604020202020204" pitchFamily="34" charset="0"/>
+              <a:buChar char="•"/>
+              <a:defRPr sz="1800" kern="1200">
+                <a:solidFill>
+                  <a:schemeClr val="tx1"/>
+                </a:solidFill>
+                <a:latin typeface="+mn-lt"/>
+                <a:ea typeface="+mn-ea"/>
+                <a:cs typeface="+mn-cs"/>
+              </a:defRPr>
+            </a:lvl5pPr>
+            <a:lvl6pPr marL="2514600" indent="-228600" algn="l" defTabSz="914400" rtl="0" eaLnBrk="1" latinLnBrk="0" hangingPunct="1">
+              <a:lnSpc>
+                <a:spcPct val="90000"/>
+              </a:lnSpc>
+              <a:spcBef>
+                <a:spcPts val="500"/>
+              </a:spcBef>
+              <a:buFont typeface="Arial" panose="020B0604020202020204" pitchFamily="34" charset="0"/>
+              <a:buChar char="•"/>
+              <a:defRPr sz="1800" kern="1200">
+                <a:solidFill>
+                  <a:schemeClr val="tx1"/>
+                </a:solidFill>
+                <a:latin typeface="+mn-lt"/>
+                <a:ea typeface="+mn-ea"/>
+                <a:cs typeface="+mn-cs"/>
+              </a:defRPr>
+            </a:lvl6pPr>
+            <a:lvl7pPr marL="2971800" indent="-228600" algn="l" defTabSz="914400" rtl="0" eaLnBrk="1" latinLnBrk="0" hangingPunct="1">
+              <a:lnSpc>
+                <a:spcPct val="90000"/>
+              </a:lnSpc>
+              <a:spcBef>
+                <a:spcPts val="500"/>
+              </a:spcBef>
+              <a:buFont typeface="Arial" panose="020B0604020202020204" pitchFamily="34" charset="0"/>
+              <a:buChar char="•"/>
+              <a:defRPr sz="1800" kern="1200">
+                <a:solidFill>
+                  <a:schemeClr val="tx1"/>
+                </a:solidFill>
+                <a:latin typeface="+mn-lt"/>
+                <a:ea typeface="+mn-ea"/>
+                <a:cs typeface="+mn-cs"/>
+              </a:defRPr>
+            </a:lvl7pPr>
+            <a:lvl8pPr marL="3429000" indent="-228600" algn="l" defTabSz="914400" rtl="0" eaLnBrk="1" latinLnBrk="0" hangingPunct="1">
+              <a:lnSpc>
+                <a:spcPct val="90000"/>
+              </a:lnSpc>
+              <a:spcBef>
+                <a:spcPts val="500"/>
+              </a:spcBef>
+              <a:buFont typeface="Arial" panose="020B0604020202020204" pitchFamily="34" charset="0"/>
+              <a:buChar char="•"/>
+              <a:defRPr sz="1800" kern="1200">
+                <a:solidFill>
+                  <a:schemeClr val="tx1"/>
+                </a:solidFill>
+                <a:latin typeface="+mn-lt"/>
+                <a:ea typeface="+mn-ea"/>
+                <a:cs typeface="+mn-cs"/>
+              </a:defRPr>
+            </a:lvl8pPr>
+            <a:lvl9pPr marL="3886200" indent="-228600" algn="l" defTabSz="914400" rtl="0" eaLnBrk="1" latinLnBrk="0" hangingPunct="1">
+              <a:lnSpc>
+                <a:spcPct val="90000"/>
+              </a:lnSpc>
+              <a:spcBef>
+                <a:spcPts val="500"/>
+              </a:spcBef>
+              <a:buFont typeface="Arial" panose="020B0604020202020204" pitchFamily="34" charset="0"/>
+              <a:buChar char="•"/>
+              <a:defRPr sz="1800" kern="1200">
+                <a:solidFill>
+                  <a:schemeClr val="tx1"/>
+                </a:solidFill>
+                <a:latin typeface="+mn-lt"/>
+                <a:ea typeface="+mn-ea"/>
+                <a:cs typeface="+mn-cs"/>
+              </a:defRPr>
+            </a:lvl9pPr>
+          </a:lstStyle>
+          <a:p>
+            <a:pPr marL="0" indent="0">
+              <a:buNone/>
+            </a:pPr>
+            <a:r>
+              <a:rPr lang="en-GB" sz="2400" dirty="0">
+                <a:solidFill>
+                  <a:schemeClr val="tx1">
+                    <a:lumMod val="50000"/>
+                    <a:lumOff val="50000"/>
+                  </a:schemeClr>
+                </a:solidFill>
+              </a:rPr>
+              <a:t>arXiv:2305.14314</a:t>
+            </a:r>
+            <a:endParaRPr lang="en-US" sz="2400" dirty="0">
+              <a:solidFill>
+                <a:schemeClr val="tx1">
+                  <a:lumMod val="50000"/>
+                  <a:lumOff val="50000"/>
+                </a:schemeClr>
+              </a:solidFill>
+            </a:endParaRPr>
+          </a:p>
+          <a:p>
+            <a:endParaRPr lang="en-US" sz="2400" dirty="0">
+              <a:solidFill>
+                <a:schemeClr val="tx1">
+                  <a:lumMod val="50000"/>
+                  <a:lumOff val="50000"/>
+                </a:schemeClr>
+              </a:solidFill>
+            </a:endParaRPr>
+          </a:p>
+        </p:txBody>
+      </p:sp>
+    </p:spTree>
+    <p:extLst>
+      <p:ext uri="{BB962C8B-B14F-4D97-AF65-F5344CB8AC3E}">
+        <p14:creationId xmlns:p14="http://schemas.microsoft.com/office/powerpoint/2010/main" val="3811858916"/>
       </p:ext>
     </p:extLst>
   </p:cSld>
@@ -12821,334 +11929,6 @@
     <p:extLst>
       <p:ext uri="{BB962C8B-B14F-4D97-AF65-F5344CB8AC3E}">
         <p14:creationId xmlns:p14="http://schemas.microsoft.com/office/powerpoint/2010/main" val="4068911658"/>
-      </p:ext>
-    </p:extLst>
-  </p:cSld>
-  <p:clrMapOvr>
-    <a:masterClrMapping/>
-  </p:clrMapOvr>
-</p:sld>
-</file>
-
-<file path=ppt/slides/slide20.xml><?xml version="1.0" encoding="utf-8"?>
-<p:sld xmlns:a="http://schemas.openxmlformats.org/drawingml/2006/main" xmlns:r="http://schemas.openxmlformats.org/officeDocument/2006/relationships" xmlns:p="http://schemas.openxmlformats.org/presentationml/2006/main">
-  <p:cSld>
-    <p:spTree>
-      <p:nvGrpSpPr>
-        <p:cNvPr id="1" name=""/>
-        <p:cNvGrpSpPr/>
-        <p:nvPr/>
-      </p:nvGrpSpPr>
-      <p:grpSpPr>
-        <a:xfrm>
-          <a:off x="0" y="0"/>
-          <a:ext cx="0" cy="0"/>
-          <a:chOff x="0" y="0"/>
-          <a:chExt cx="0" cy="0"/>
-        </a:xfrm>
-      </p:grpSpPr>
-      <p:sp>
-        <p:nvSpPr>
-          <p:cNvPr id="4" name="Title 1">
-            <a:extLst>
-              <a:ext uri="{FF2B5EF4-FFF2-40B4-BE49-F238E27FC236}">
-                <a16:creationId xmlns:a16="http://schemas.microsoft.com/office/drawing/2014/main" id="{DF00D04C-A321-D685-8023-6DC42CB3EA55}"/>
-              </a:ext>
-            </a:extLst>
-          </p:cNvPr>
-          <p:cNvSpPr>
-            <a:spLocks noGrp="1"/>
-          </p:cNvSpPr>
-          <p:nvPr>
-            <p:ph type="title"/>
-          </p:nvPr>
-        </p:nvSpPr>
-        <p:spPr>
-          <a:xfrm>
-            <a:off x="838199" y="365125"/>
-            <a:ext cx="10790583" cy="1325563"/>
-          </a:xfrm>
-        </p:spPr>
-        <p:txBody>
-          <a:bodyPr/>
-          <a:lstStyle/>
-          <a:p>
-            <a:r>
-              <a:rPr lang="en-US" dirty="0"/>
-              <a:t>Quantized Low Rank Adaptation (</a:t>
-            </a:r>
-            <a:r>
-              <a:rPr lang="en-US" dirty="0" err="1"/>
-              <a:t>qLoRA</a:t>
-            </a:r>
-            <a:r>
-              <a:rPr lang="en-US" dirty="0"/>
-              <a:t>)</a:t>
-            </a:r>
-          </a:p>
-        </p:txBody>
-      </p:sp>
-      <p:pic>
-        <p:nvPicPr>
-          <p:cNvPr id="5" name="Picture 4">
-            <a:extLst>
-              <a:ext uri="{FF2B5EF4-FFF2-40B4-BE49-F238E27FC236}">
-                <a16:creationId xmlns:a16="http://schemas.microsoft.com/office/drawing/2014/main" id="{2027358D-2B46-8E48-4FB6-D4A9B320DC2A}"/>
-              </a:ext>
-            </a:extLst>
-          </p:cNvPr>
-          <p:cNvPicPr>
-            <a:picLocks noChangeAspect="1"/>
-          </p:cNvPicPr>
-          <p:nvPr/>
-        </p:nvPicPr>
-        <p:blipFill>
-          <a:blip r:embed="rId2"/>
-          <a:stretch>
-            <a:fillRect/>
-          </a:stretch>
-        </p:blipFill>
-        <p:spPr>
-          <a:xfrm>
-            <a:off x="2209800" y="2282085"/>
-            <a:ext cx="7772400" cy="2949814"/>
-          </a:xfrm>
-          <a:prstGeom prst="rect">
-            <a:avLst/>
-          </a:prstGeom>
-        </p:spPr>
-      </p:pic>
-      <p:sp>
-        <p:nvSpPr>
-          <p:cNvPr id="6" name="Content Placeholder 2">
-            <a:extLst>
-              <a:ext uri="{FF2B5EF4-FFF2-40B4-BE49-F238E27FC236}">
-                <a16:creationId xmlns:a16="http://schemas.microsoft.com/office/drawing/2014/main" id="{FA5E7CB3-008B-3B87-BE55-E3D113772078}"/>
-              </a:ext>
-            </a:extLst>
-          </p:cNvPr>
-          <p:cNvSpPr txBox="1">
-            <a:spLocks/>
-          </p:cNvSpPr>
-          <p:nvPr/>
-        </p:nvSpPr>
-        <p:spPr>
-          <a:xfrm>
-            <a:off x="9253420" y="6136205"/>
-            <a:ext cx="3118738" cy="529390"/>
-          </a:xfrm>
-          <a:prstGeom prst="rect">
-            <a:avLst/>
-          </a:prstGeom>
-        </p:spPr>
-        <p:txBody>
-          <a:bodyPr vert="horz" lIns="91440" tIns="45720" rIns="91440" bIns="45720" rtlCol="0">
-            <a:normAutofit/>
-          </a:bodyPr>
-          <a:lstStyle>
-            <a:lvl1pPr marL="228600" indent="-228600" algn="l" defTabSz="914400" rtl="0" eaLnBrk="1" latinLnBrk="0" hangingPunct="1">
-              <a:lnSpc>
-                <a:spcPct val="90000"/>
-              </a:lnSpc>
-              <a:spcBef>
-                <a:spcPts val="1000"/>
-              </a:spcBef>
-              <a:buFont typeface="Arial" panose="020B0604020202020204" pitchFamily="34" charset="0"/>
-              <a:buChar char="•"/>
-              <a:defRPr sz="2800" kern="1200">
-                <a:solidFill>
-                  <a:schemeClr val="tx1"/>
-                </a:solidFill>
-                <a:latin typeface="+mn-lt"/>
-                <a:ea typeface="+mn-ea"/>
-                <a:cs typeface="+mn-cs"/>
-              </a:defRPr>
-            </a:lvl1pPr>
-            <a:lvl2pPr marL="685800" indent="-228600" algn="l" defTabSz="914400" rtl="0" eaLnBrk="1" latinLnBrk="0" hangingPunct="1">
-              <a:lnSpc>
-                <a:spcPct val="90000"/>
-              </a:lnSpc>
-              <a:spcBef>
-                <a:spcPts val="500"/>
-              </a:spcBef>
-              <a:buFont typeface="Arial" panose="020B0604020202020204" pitchFamily="34" charset="0"/>
-              <a:buChar char="•"/>
-              <a:defRPr sz="2400" kern="1200">
-                <a:solidFill>
-                  <a:schemeClr val="tx1"/>
-                </a:solidFill>
-                <a:latin typeface="+mn-lt"/>
-                <a:ea typeface="+mn-ea"/>
-                <a:cs typeface="+mn-cs"/>
-              </a:defRPr>
-            </a:lvl2pPr>
-            <a:lvl3pPr marL="1143000" indent="-228600" algn="l" defTabSz="914400" rtl="0" eaLnBrk="1" latinLnBrk="0" hangingPunct="1">
-              <a:lnSpc>
-                <a:spcPct val="90000"/>
-              </a:lnSpc>
-              <a:spcBef>
-                <a:spcPts val="500"/>
-              </a:spcBef>
-              <a:buFont typeface="Arial" panose="020B0604020202020204" pitchFamily="34" charset="0"/>
-              <a:buChar char="•"/>
-              <a:defRPr sz="2000" kern="1200">
-                <a:solidFill>
-                  <a:schemeClr val="tx1"/>
-                </a:solidFill>
-                <a:latin typeface="+mn-lt"/>
-                <a:ea typeface="+mn-ea"/>
-                <a:cs typeface="+mn-cs"/>
-              </a:defRPr>
-            </a:lvl3pPr>
-            <a:lvl4pPr marL="1600200" indent="-228600" algn="l" defTabSz="914400" rtl="0" eaLnBrk="1" latinLnBrk="0" hangingPunct="1">
-              <a:lnSpc>
-                <a:spcPct val="90000"/>
-              </a:lnSpc>
-              <a:spcBef>
-                <a:spcPts val="500"/>
-              </a:spcBef>
-              <a:buFont typeface="Arial" panose="020B0604020202020204" pitchFamily="34" charset="0"/>
-              <a:buChar char="•"/>
-              <a:defRPr sz="1800" kern="1200">
-                <a:solidFill>
-                  <a:schemeClr val="tx1"/>
-                </a:solidFill>
-                <a:latin typeface="+mn-lt"/>
-                <a:ea typeface="+mn-ea"/>
-                <a:cs typeface="+mn-cs"/>
-              </a:defRPr>
-            </a:lvl4pPr>
-            <a:lvl5pPr marL="2057400" indent="-228600" algn="l" defTabSz="914400" rtl="0" eaLnBrk="1" latinLnBrk="0" hangingPunct="1">
-              <a:lnSpc>
-                <a:spcPct val="90000"/>
-              </a:lnSpc>
-              <a:spcBef>
-                <a:spcPts val="500"/>
-              </a:spcBef>
-              <a:buFont typeface="Arial" panose="020B0604020202020204" pitchFamily="34" charset="0"/>
-              <a:buChar char="•"/>
-              <a:defRPr sz="1800" kern="1200">
-                <a:solidFill>
-                  <a:schemeClr val="tx1"/>
-                </a:solidFill>
-                <a:latin typeface="+mn-lt"/>
-                <a:ea typeface="+mn-ea"/>
-                <a:cs typeface="+mn-cs"/>
-              </a:defRPr>
-            </a:lvl5pPr>
-            <a:lvl6pPr marL="2514600" indent="-228600" algn="l" defTabSz="914400" rtl="0" eaLnBrk="1" latinLnBrk="0" hangingPunct="1">
-              <a:lnSpc>
-                <a:spcPct val="90000"/>
-              </a:lnSpc>
-              <a:spcBef>
-                <a:spcPts val="500"/>
-              </a:spcBef>
-              <a:buFont typeface="Arial" panose="020B0604020202020204" pitchFamily="34" charset="0"/>
-              <a:buChar char="•"/>
-              <a:defRPr sz="1800" kern="1200">
-                <a:solidFill>
-                  <a:schemeClr val="tx1"/>
-                </a:solidFill>
-                <a:latin typeface="+mn-lt"/>
-                <a:ea typeface="+mn-ea"/>
-                <a:cs typeface="+mn-cs"/>
-              </a:defRPr>
-            </a:lvl6pPr>
-            <a:lvl7pPr marL="2971800" indent="-228600" algn="l" defTabSz="914400" rtl="0" eaLnBrk="1" latinLnBrk="0" hangingPunct="1">
-              <a:lnSpc>
-                <a:spcPct val="90000"/>
-              </a:lnSpc>
-              <a:spcBef>
-                <a:spcPts val="500"/>
-              </a:spcBef>
-              <a:buFont typeface="Arial" panose="020B0604020202020204" pitchFamily="34" charset="0"/>
-              <a:buChar char="•"/>
-              <a:defRPr sz="1800" kern="1200">
-                <a:solidFill>
-                  <a:schemeClr val="tx1"/>
-                </a:solidFill>
-                <a:latin typeface="+mn-lt"/>
-                <a:ea typeface="+mn-ea"/>
-                <a:cs typeface="+mn-cs"/>
-              </a:defRPr>
-            </a:lvl7pPr>
-            <a:lvl8pPr marL="3429000" indent="-228600" algn="l" defTabSz="914400" rtl="0" eaLnBrk="1" latinLnBrk="0" hangingPunct="1">
-              <a:lnSpc>
-                <a:spcPct val="90000"/>
-              </a:lnSpc>
-              <a:spcBef>
-                <a:spcPts val="500"/>
-              </a:spcBef>
-              <a:buFont typeface="Arial" panose="020B0604020202020204" pitchFamily="34" charset="0"/>
-              <a:buChar char="•"/>
-              <a:defRPr sz="1800" kern="1200">
-                <a:solidFill>
-                  <a:schemeClr val="tx1"/>
-                </a:solidFill>
-                <a:latin typeface="+mn-lt"/>
-                <a:ea typeface="+mn-ea"/>
-                <a:cs typeface="+mn-cs"/>
-              </a:defRPr>
-            </a:lvl8pPr>
-            <a:lvl9pPr marL="3886200" indent="-228600" algn="l" defTabSz="914400" rtl="0" eaLnBrk="1" latinLnBrk="0" hangingPunct="1">
-              <a:lnSpc>
-                <a:spcPct val="90000"/>
-              </a:lnSpc>
-              <a:spcBef>
-                <a:spcPts val="500"/>
-              </a:spcBef>
-              <a:buFont typeface="Arial" panose="020B0604020202020204" pitchFamily="34" charset="0"/>
-              <a:buChar char="•"/>
-              <a:defRPr sz="1800" kern="1200">
-                <a:solidFill>
-                  <a:schemeClr val="tx1"/>
-                </a:solidFill>
-                <a:latin typeface="+mn-lt"/>
-                <a:ea typeface="+mn-ea"/>
-                <a:cs typeface="+mn-cs"/>
-              </a:defRPr>
-            </a:lvl9pPr>
-          </a:lstStyle>
-          <a:p>
-            <a:pPr marL="0" indent="0">
-              <a:buNone/>
-            </a:pPr>
-            <a:r>
-              <a:rPr lang="en-GB" sz="2400" dirty="0">
-                <a:solidFill>
-                  <a:schemeClr val="tx1">
-                    <a:lumMod val="50000"/>
-                    <a:lumOff val="50000"/>
-                  </a:schemeClr>
-                </a:solidFill>
-              </a:rPr>
-              <a:t>arXiv:2305.14314</a:t>
-            </a:r>
-            <a:endParaRPr lang="en-US" sz="2400" dirty="0">
-              <a:solidFill>
-                <a:schemeClr val="tx1">
-                  <a:lumMod val="50000"/>
-                  <a:lumOff val="50000"/>
-                </a:schemeClr>
-              </a:solidFill>
-            </a:endParaRPr>
-          </a:p>
-          <a:p>
-            <a:endParaRPr lang="en-US" sz="2400" dirty="0">
-              <a:solidFill>
-                <a:schemeClr val="tx1">
-                  <a:lumMod val="50000"/>
-                  <a:lumOff val="50000"/>
-                </a:schemeClr>
-              </a:solidFill>
-            </a:endParaRPr>
-          </a:p>
-        </p:txBody>
-      </p:sp>
-    </p:spTree>
-    <p:extLst>
-      <p:ext uri="{BB962C8B-B14F-4D97-AF65-F5344CB8AC3E}">
-        <p14:creationId xmlns:p14="http://schemas.microsoft.com/office/powerpoint/2010/main" val="3811858916"/>
       </p:ext>
     </p:extLst>
   </p:cSld>
@@ -14671,188 +13451,6 @@
 </file>
 
 <file path=ppt/slides/slide8.xml><?xml version="1.0" encoding="utf-8"?>
-<p:sld xmlns:a="http://schemas.openxmlformats.org/drawingml/2006/main" xmlns:r="http://schemas.openxmlformats.org/officeDocument/2006/relationships" xmlns:p="http://schemas.openxmlformats.org/presentationml/2006/main">
-  <p:cSld>
-    <p:spTree>
-      <p:nvGrpSpPr>
-        <p:cNvPr id="1" name=""/>
-        <p:cNvGrpSpPr/>
-        <p:nvPr/>
-      </p:nvGrpSpPr>
-      <p:grpSpPr>
-        <a:xfrm>
-          <a:off x="0" y="0"/>
-          <a:ext cx="0" cy="0"/>
-          <a:chOff x="0" y="0"/>
-          <a:chExt cx="0" cy="0"/>
-        </a:xfrm>
-      </p:grpSpPr>
-      <p:sp>
-        <p:nvSpPr>
-          <p:cNvPr id="2" name="Title 1">
-            <a:extLst>
-              <a:ext uri="{FF2B5EF4-FFF2-40B4-BE49-F238E27FC236}">
-                <a16:creationId xmlns:a16="http://schemas.microsoft.com/office/drawing/2014/main" id="{85ACDFEA-AE46-A8D2-6349-F12A48FDAA89}"/>
-              </a:ext>
-            </a:extLst>
-          </p:cNvPr>
-          <p:cNvSpPr>
-            <a:spLocks noGrp="1"/>
-          </p:cNvSpPr>
-          <p:nvPr>
-            <p:ph type="title"/>
-          </p:nvPr>
-        </p:nvSpPr>
-        <p:spPr/>
-        <p:txBody>
-          <a:bodyPr/>
-          <a:lstStyle/>
-          <a:p>
-            <a:r>
-              <a:rPr lang="en-GB" dirty="0"/>
-              <a:t>Alpaca</a:t>
-            </a:r>
-          </a:p>
-        </p:txBody>
-      </p:sp>
-      <p:sp>
-        <p:nvSpPr>
-          <p:cNvPr id="3" name="Content Placeholder 2">
-            <a:extLst>
-              <a:ext uri="{FF2B5EF4-FFF2-40B4-BE49-F238E27FC236}">
-                <a16:creationId xmlns:a16="http://schemas.microsoft.com/office/drawing/2014/main" id="{FCCE7A79-CEF0-24C7-E9CF-8A728F33B614}"/>
-              </a:ext>
-            </a:extLst>
-          </p:cNvPr>
-          <p:cNvSpPr>
-            <a:spLocks noGrp="1"/>
-          </p:cNvSpPr>
-          <p:nvPr>
-            <p:ph idx="1"/>
-          </p:nvPr>
-        </p:nvSpPr>
-        <p:spPr/>
-        <p:txBody>
-          <a:bodyPr vert="horz" lIns="91440" tIns="45720" rIns="91440" bIns="45720" rtlCol="0" anchor="t">
-            <a:normAutofit/>
-          </a:bodyPr>
-          <a:lstStyle/>
-          <a:p>
-            <a:pPr marL="0" indent="0">
-              <a:buNone/>
-            </a:pPr>
-            <a:r>
-              <a:rPr lang="en-GB" sz="1800" dirty="0">
-                <a:latin typeface="IBM Plex Mono"/>
-              </a:rPr>
-              <a:t>Below is an instruction that describes a task. Write a response that appropriately completes the request.</a:t>
-            </a:r>
-            <a:endParaRPr lang="en-US" sz="1800">
-              <a:latin typeface="Aptos" panose="020B0004020202020204"/>
-            </a:endParaRPr>
-          </a:p>
-          <a:p>
-            <a:pPr marL="0" indent="0">
-              <a:buNone/>
-            </a:pPr>
-            <a:endParaRPr lang="en-GB" sz="1800" dirty="0">
-              <a:latin typeface="IBM Plex Mono"/>
-            </a:endParaRPr>
-          </a:p>
-          <a:p>
-            <a:pPr marL="0" indent="0">
-              <a:buNone/>
-            </a:pPr>
-            <a:r>
-              <a:rPr lang="en-GB" sz="1800" dirty="0">
-                <a:latin typeface="IBM Plex Mono"/>
-              </a:rPr>
-              <a:t>### Instruction:</a:t>
-            </a:r>
-            <a:endParaRPr lang="en-US" sz="1800">
-              <a:latin typeface="Aptos" panose="020B0004020202020204"/>
-            </a:endParaRPr>
-          </a:p>
-          <a:p>
-            <a:pPr marL="0" indent="0">
-              <a:buNone/>
-            </a:pPr>
-            <a:r>
-              <a:rPr lang="en-GB" sz="1800" dirty="0">
-                <a:latin typeface="IBM Plex Mono"/>
-              </a:rPr>
-              <a:t>Discuss the causes of the Great Depression</a:t>
-            </a:r>
-            <a:endParaRPr lang="en-US" sz="1800">
-              <a:latin typeface="Aptos" panose="020B0004020202020204"/>
-            </a:endParaRPr>
-          </a:p>
-          <a:p>
-            <a:pPr marL="0" indent="0">
-              <a:buNone/>
-            </a:pPr>
-            <a:endParaRPr lang="en-GB" sz="1800" dirty="0">
-              <a:latin typeface="IBM Plex Mono"/>
-            </a:endParaRPr>
-          </a:p>
-          <a:p>
-            <a:pPr marL="0" indent="0">
-              <a:buNone/>
-            </a:pPr>
-            <a:r>
-              <a:rPr lang="en-GB" sz="1800" dirty="0">
-                <a:latin typeface="IBM Plex Mono"/>
-              </a:rPr>
-              <a:t>### Response:</a:t>
-            </a:r>
-            <a:endParaRPr lang="en-GB" sz="1800" dirty="0">
-              <a:latin typeface="Aptos" panose="020B0004020202020204"/>
-            </a:endParaRPr>
-          </a:p>
-          <a:p>
-            <a:pPr marL="0" indent="0">
-              <a:buNone/>
-            </a:pPr>
-            <a:r>
-              <a:rPr lang="en-GB" sz="1800" dirty="0">
-                <a:latin typeface="IBM Plex Mono"/>
-              </a:rPr>
-              <a:t>The Great Depression was a severe global economic downturn that lasted from 1929 to 1939. It was caused by several factors, including the stock market crash of 1929, structural weaknesses in the economy, low consumer spending, high unemployment, and a lack of confidence in the banking system. Other contributing factors included overproduction of commodities, reliance on borrowing to finance investments, agricultural overproduction, and a decrease in international trade.</a:t>
-            </a:r>
-            <a:endParaRPr lang="en-GB" sz="1800"/>
-          </a:p>
-          <a:p>
-            <a:pPr marL="0" indent="0">
-              <a:buNone/>
-            </a:pPr>
-            <a:endParaRPr lang="en-GB" sz="900" dirty="0">
-              <a:latin typeface="IBM Plex Mono"/>
-            </a:endParaRPr>
-          </a:p>
-          <a:p>
-            <a:pPr marL="0" indent="0">
-              <a:buNone/>
-            </a:pPr>
-            <a:endParaRPr lang="en-GB" sz="900" dirty="0">
-              <a:latin typeface="IBM Plex Mono"/>
-            </a:endParaRPr>
-          </a:p>
-        </p:txBody>
-      </p:sp>
-    </p:spTree>
-    <p:extLst>
-      <p:ext uri="{BB962C8B-B14F-4D97-AF65-F5344CB8AC3E}">
-        <p14:creationId xmlns:p14="http://schemas.microsoft.com/office/powerpoint/2010/main" val="155390671"/>
-      </p:ext>
-    </p:extLst>
-  </p:cSld>
-  <p:clrMapOvr>
-    <a:masterClrMapping/>
-  </p:clrMapOvr>
-</p:sld>
-</file>
-
-<file path=ppt/slides/slide9.xml><?xml version="1.0" encoding="utf-8"?>
 <p:sld xmlns:a="http://schemas.openxmlformats.org/drawingml/2006/main" xmlns:r="http://schemas.openxmlformats.org/officeDocument/2006/relationships" xmlns:p="http://schemas.openxmlformats.org/presentationml/2006/main">
   <p:cSld>
     <p:spTree>
@@ -17041,6 +15639,1181 @@
       <p:bldP spid="12" grpId="0" animBg="1"/>
       <p:bldP spid="13" grpId="0" animBg="1"/>
       <p:bldP spid="14" grpId="0"/>
+    </p:bldLst>
+  </p:timing>
+</p:sld>
+</file>
+
+<file path=ppt/slides/slide9.xml><?xml version="1.0" encoding="utf-8"?>
+<p:sld xmlns:a="http://schemas.openxmlformats.org/drawingml/2006/main" xmlns:r="http://schemas.openxmlformats.org/officeDocument/2006/relationships" xmlns:p="http://schemas.openxmlformats.org/presentationml/2006/main">
+  <p:cSld>
+    <p:spTree>
+      <p:nvGrpSpPr>
+        <p:cNvPr id="1" name="">
+          <a:extLst>
+            <a:ext uri="{FF2B5EF4-FFF2-40B4-BE49-F238E27FC236}">
+              <a16:creationId xmlns:a16="http://schemas.microsoft.com/office/drawing/2014/main" id="{09EDFC20-C59B-41D6-68AD-1540FFC43D98}"/>
+            </a:ext>
+          </a:extLst>
+        </p:cNvPr>
+        <p:cNvGrpSpPr/>
+        <p:nvPr/>
+      </p:nvGrpSpPr>
+      <p:grpSpPr>
+        <a:xfrm>
+          <a:off x="0" y="0"/>
+          <a:ext cx="0" cy="0"/>
+          <a:chOff x="0" y="0"/>
+          <a:chExt cx="0" cy="0"/>
+        </a:xfrm>
+      </p:grpSpPr>
+      <p:sp>
+        <p:nvSpPr>
+          <p:cNvPr id="2" name="Title 1">
+            <a:extLst>
+              <a:ext uri="{FF2B5EF4-FFF2-40B4-BE49-F238E27FC236}">
+                <a16:creationId xmlns:a16="http://schemas.microsoft.com/office/drawing/2014/main" id="{035EAA1E-A777-8CAB-4628-80086C03E001}"/>
+              </a:ext>
+            </a:extLst>
+          </p:cNvPr>
+          <p:cNvSpPr>
+            <a:spLocks noGrp="1"/>
+          </p:cNvSpPr>
+          <p:nvPr>
+            <p:ph type="title"/>
+          </p:nvPr>
+        </p:nvSpPr>
+        <p:spPr/>
+        <p:txBody>
+          <a:bodyPr/>
+          <a:lstStyle/>
+          <a:p>
+            <a:r>
+              <a:rPr lang="en-GB" dirty="0"/>
+              <a:t>Instruction tuning</a:t>
+            </a:r>
+            <a:endParaRPr lang="en-US" dirty="0"/>
+          </a:p>
+        </p:txBody>
+      </p:sp>
+      <p:sp>
+        <p:nvSpPr>
+          <p:cNvPr id="3" name="Content Placeholder 2">
+            <a:extLst>
+              <a:ext uri="{FF2B5EF4-FFF2-40B4-BE49-F238E27FC236}">
+                <a16:creationId xmlns:a16="http://schemas.microsoft.com/office/drawing/2014/main" id="{13F805AE-B7E0-24C4-B1B5-46870D07445A}"/>
+              </a:ext>
+            </a:extLst>
+          </p:cNvPr>
+          <p:cNvSpPr>
+            <a:spLocks noGrp="1"/>
+          </p:cNvSpPr>
+          <p:nvPr>
+            <p:ph idx="1"/>
+          </p:nvPr>
+        </p:nvSpPr>
+        <p:spPr/>
+        <p:txBody>
+          <a:bodyPr vert="horz" lIns="91440" tIns="45720" rIns="91440" bIns="45720" rtlCol="0" anchor="t">
+            <a:normAutofit/>
+          </a:bodyPr>
+          <a:lstStyle/>
+          <a:p>
+            <a:pPr marL="0" indent="0">
+              <a:lnSpc>
+                <a:spcPct val="114999"/>
+              </a:lnSpc>
+              <a:spcBef>
+                <a:spcPts val="0"/>
+              </a:spcBef>
+              <a:buNone/>
+            </a:pPr>
+            <a:r>
+              <a:rPr lang="en-GB" sz="1700" dirty="0">
+                <a:solidFill>
+                  <a:srgbClr val="666666"/>
+                </a:solidFill>
+                <a:latin typeface="Source Code Pro"/>
+                <a:ea typeface="Source Code Pro"/>
+              </a:rPr>
+              <a:t>&lt;|</a:t>
+            </a:r>
+            <a:r>
+              <a:rPr lang="en-GB" sz="1700" dirty="0" err="1">
+                <a:solidFill>
+                  <a:srgbClr val="666666"/>
+                </a:solidFill>
+                <a:latin typeface="Source Code Pro"/>
+                <a:ea typeface="Source Code Pro"/>
+              </a:rPr>
+              <a:t>begin_of_text</a:t>
+            </a:r>
+            <a:r>
+              <a:rPr lang="en-GB" sz="1700" dirty="0">
+                <a:solidFill>
+                  <a:srgbClr val="666666"/>
+                </a:solidFill>
+                <a:latin typeface="Source Code Pro"/>
+                <a:ea typeface="Source Code Pro"/>
+              </a:rPr>
+              <a:t>|&gt;&lt;|</a:t>
+            </a:r>
+            <a:r>
+              <a:rPr lang="en-GB" sz="1700" dirty="0" err="1">
+                <a:solidFill>
+                  <a:srgbClr val="666666"/>
+                </a:solidFill>
+                <a:latin typeface="Source Code Pro"/>
+                <a:ea typeface="Source Code Pro"/>
+              </a:rPr>
+              <a:t>start_header_id</a:t>
+            </a:r>
+            <a:r>
+              <a:rPr lang="en-GB" sz="1700" dirty="0">
+                <a:solidFill>
+                  <a:srgbClr val="666666"/>
+                </a:solidFill>
+                <a:latin typeface="Source Code Pro"/>
+                <a:ea typeface="Source Code Pro"/>
+              </a:rPr>
+              <a:t>|&gt;</a:t>
+            </a:r>
+            <a:r>
+              <a:rPr lang="en-GB" sz="1700" dirty="0">
+                <a:solidFill>
+                  <a:srgbClr val="0B7743"/>
+                </a:solidFill>
+                <a:latin typeface="Source Code Pro"/>
+                <a:ea typeface="Source Code Pro"/>
+              </a:rPr>
+              <a:t>system</a:t>
+            </a:r>
+            <a:r>
+              <a:rPr lang="en-GB" sz="1700" dirty="0">
+                <a:solidFill>
+                  <a:srgbClr val="666666"/>
+                </a:solidFill>
+                <a:latin typeface="Source Code Pro"/>
+                <a:ea typeface="Source Code Pro"/>
+              </a:rPr>
+              <a:t>&lt;|</a:t>
+            </a:r>
+            <a:r>
+              <a:rPr lang="en-GB" sz="1700" dirty="0" err="1">
+                <a:solidFill>
+                  <a:srgbClr val="666666"/>
+                </a:solidFill>
+                <a:latin typeface="Source Code Pro"/>
+                <a:ea typeface="Source Code Pro"/>
+              </a:rPr>
+              <a:t>end_header_id</a:t>
+            </a:r>
+            <a:r>
+              <a:rPr lang="en-GB" sz="1700" dirty="0">
+                <a:solidFill>
+                  <a:srgbClr val="666666"/>
+                </a:solidFill>
+                <a:latin typeface="Source Code Pro"/>
+                <a:ea typeface="Source Code Pro"/>
+              </a:rPr>
+              <a:t>|&gt;</a:t>
+            </a:r>
+            <a:endParaRPr lang="en-US" sz="1700" dirty="0">
+              <a:solidFill>
+                <a:srgbClr val="00FDC8"/>
+              </a:solidFill>
+              <a:latin typeface="Source Code Pro"/>
+              <a:ea typeface="Source Code Pro"/>
+            </a:endParaRPr>
+          </a:p>
+          <a:p>
+            <a:pPr marL="0" indent="0">
+              <a:lnSpc>
+                <a:spcPct val="114999"/>
+              </a:lnSpc>
+              <a:spcBef>
+                <a:spcPts val="1200"/>
+              </a:spcBef>
+              <a:buNone/>
+            </a:pPr>
+            <a:r>
+              <a:rPr lang="en-GB" sz="1700" dirty="0">
+                <a:solidFill>
+                  <a:srgbClr val="9325A5"/>
+                </a:solidFill>
+                <a:latin typeface="Source Code Pro"/>
+                <a:ea typeface="Source Code Pro"/>
+              </a:rPr>
+              <a:t>You are an expert in baking.</a:t>
+            </a:r>
+            <a:r>
+              <a:rPr lang="en-GB" sz="1700" dirty="0">
+                <a:solidFill>
+                  <a:srgbClr val="666666"/>
+                </a:solidFill>
+                <a:latin typeface="Source Code Pro"/>
+                <a:ea typeface="Source Code Pro"/>
+              </a:rPr>
+              <a:t>&lt;|</a:t>
+            </a:r>
+            <a:r>
+              <a:rPr lang="en-GB" sz="1700" dirty="0" err="1">
+                <a:solidFill>
+                  <a:srgbClr val="666666"/>
+                </a:solidFill>
+                <a:latin typeface="Source Code Pro"/>
+                <a:ea typeface="Source Code Pro"/>
+              </a:rPr>
+              <a:t>eot_id</a:t>
+            </a:r>
+            <a:r>
+              <a:rPr lang="en-GB" sz="1700" dirty="0">
+                <a:solidFill>
+                  <a:srgbClr val="666666"/>
+                </a:solidFill>
+                <a:latin typeface="Source Code Pro"/>
+                <a:ea typeface="Source Code Pro"/>
+              </a:rPr>
+              <a:t>|&gt;</a:t>
+            </a:r>
+            <a:endParaRPr lang="en-US" sz="1700" dirty="0">
+              <a:solidFill>
+                <a:srgbClr val="00FDC8"/>
+              </a:solidFill>
+              <a:latin typeface="Source Code Pro"/>
+              <a:ea typeface="Source Code Pro"/>
+            </a:endParaRPr>
+          </a:p>
+          <a:p>
+            <a:pPr marL="0" indent="0">
+              <a:lnSpc>
+                <a:spcPct val="114999"/>
+              </a:lnSpc>
+              <a:spcBef>
+                <a:spcPts val="1200"/>
+              </a:spcBef>
+              <a:buNone/>
+            </a:pPr>
+            <a:endParaRPr lang="en-GB" sz="1700" dirty="0">
+              <a:solidFill>
+                <a:srgbClr val="666666"/>
+              </a:solidFill>
+              <a:latin typeface="Source Code Pro"/>
+              <a:ea typeface="Source Code Pro"/>
+            </a:endParaRPr>
+          </a:p>
+          <a:p>
+            <a:pPr marL="0" indent="0">
+              <a:lnSpc>
+                <a:spcPct val="114999"/>
+              </a:lnSpc>
+              <a:spcBef>
+                <a:spcPts val="1200"/>
+              </a:spcBef>
+              <a:buNone/>
+            </a:pPr>
+            <a:r>
+              <a:rPr lang="en-GB" sz="1700" dirty="0">
+                <a:solidFill>
+                  <a:srgbClr val="666666"/>
+                </a:solidFill>
+                <a:latin typeface="Source Code Pro"/>
+                <a:ea typeface="Source Code Pro"/>
+              </a:rPr>
+              <a:t>&lt;|</a:t>
+            </a:r>
+            <a:r>
+              <a:rPr lang="en-GB" sz="1700" dirty="0" err="1">
+                <a:solidFill>
+                  <a:srgbClr val="666666"/>
+                </a:solidFill>
+                <a:latin typeface="Source Code Pro"/>
+                <a:ea typeface="Source Code Pro"/>
+              </a:rPr>
+              <a:t>start_header_id</a:t>
+            </a:r>
+            <a:r>
+              <a:rPr lang="en-GB" sz="1700" dirty="0">
+                <a:solidFill>
+                  <a:srgbClr val="666666"/>
+                </a:solidFill>
+                <a:latin typeface="Source Code Pro"/>
+                <a:ea typeface="Source Code Pro"/>
+              </a:rPr>
+              <a:t>|&gt;</a:t>
+            </a:r>
+            <a:r>
+              <a:rPr lang="en-GB" sz="1700" dirty="0">
+                <a:solidFill>
+                  <a:srgbClr val="0B7743"/>
+                </a:solidFill>
+                <a:latin typeface="Source Code Pro"/>
+                <a:ea typeface="Source Code Pro"/>
+              </a:rPr>
+              <a:t>user</a:t>
+            </a:r>
+            <a:r>
+              <a:rPr lang="en-GB" sz="1700" dirty="0">
+                <a:solidFill>
+                  <a:srgbClr val="666666"/>
+                </a:solidFill>
+                <a:latin typeface="Source Code Pro"/>
+                <a:ea typeface="Source Code Pro"/>
+              </a:rPr>
+              <a:t>&lt;|</a:t>
+            </a:r>
+            <a:r>
+              <a:rPr lang="en-GB" sz="1700" dirty="0" err="1">
+                <a:solidFill>
+                  <a:srgbClr val="666666"/>
+                </a:solidFill>
+                <a:latin typeface="Source Code Pro"/>
+                <a:ea typeface="Source Code Pro"/>
+              </a:rPr>
+              <a:t>end_header_id</a:t>
+            </a:r>
+            <a:r>
+              <a:rPr lang="en-GB" sz="1700" dirty="0">
+                <a:solidFill>
+                  <a:srgbClr val="666666"/>
+                </a:solidFill>
+                <a:latin typeface="Source Code Pro"/>
+                <a:ea typeface="Source Code Pro"/>
+              </a:rPr>
+              <a:t>|&gt;</a:t>
+            </a:r>
+            <a:endParaRPr lang="en-US" sz="1700" dirty="0">
+              <a:solidFill>
+                <a:srgbClr val="00FDC8"/>
+              </a:solidFill>
+              <a:latin typeface="Source Code Pro"/>
+              <a:ea typeface="Source Code Pro"/>
+            </a:endParaRPr>
+          </a:p>
+          <a:p>
+            <a:pPr marL="0" indent="0">
+              <a:lnSpc>
+                <a:spcPct val="114999"/>
+              </a:lnSpc>
+              <a:spcBef>
+                <a:spcPts val="1200"/>
+              </a:spcBef>
+              <a:buNone/>
+            </a:pPr>
+            <a:r>
+              <a:rPr lang="en-GB" sz="1700" dirty="0">
+                <a:solidFill>
+                  <a:srgbClr val="9325A5"/>
+                </a:solidFill>
+                <a:latin typeface="Source Code Pro"/>
+                <a:ea typeface="Source Code Pro"/>
+              </a:rPr>
+              <a:t>Provide me a recipe for macarons.</a:t>
+            </a:r>
+            <a:r>
+              <a:rPr lang="en-GB" sz="1700" dirty="0">
+                <a:solidFill>
+                  <a:srgbClr val="666666"/>
+                </a:solidFill>
+                <a:latin typeface="Source Code Pro"/>
+                <a:ea typeface="Source Code Pro"/>
+              </a:rPr>
+              <a:t>&lt;|</a:t>
+            </a:r>
+            <a:r>
+              <a:rPr lang="en-GB" sz="1700" err="1">
+                <a:solidFill>
+                  <a:srgbClr val="666666"/>
+                </a:solidFill>
+                <a:latin typeface="Source Code Pro"/>
+                <a:ea typeface="Source Code Pro"/>
+              </a:rPr>
+              <a:t>eot_id</a:t>
+            </a:r>
+            <a:r>
+              <a:rPr lang="en-GB" sz="1700" dirty="0">
+                <a:solidFill>
+                  <a:srgbClr val="666666"/>
+                </a:solidFill>
+                <a:latin typeface="Source Code Pro"/>
+                <a:ea typeface="Source Code Pro"/>
+              </a:rPr>
+              <a:t>|&gt;</a:t>
+            </a:r>
+            <a:endParaRPr lang="en-US" sz="1700" dirty="0">
+              <a:solidFill>
+                <a:srgbClr val="00FDC8"/>
+              </a:solidFill>
+              <a:latin typeface="Source Code Pro"/>
+              <a:ea typeface="Source Code Pro"/>
+            </a:endParaRPr>
+          </a:p>
+          <a:p>
+            <a:pPr marL="0" indent="0">
+              <a:lnSpc>
+                <a:spcPct val="114999"/>
+              </a:lnSpc>
+              <a:spcBef>
+                <a:spcPts val="1200"/>
+              </a:spcBef>
+              <a:buNone/>
+            </a:pPr>
+            <a:endParaRPr lang="en-GB" sz="1700" dirty="0">
+              <a:solidFill>
+                <a:srgbClr val="666666"/>
+              </a:solidFill>
+              <a:latin typeface="Source Code Pro"/>
+              <a:ea typeface="Source Code Pro"/>
+            </a:endParaRPr>
+          </a:p>
+          <a:p>
+            <a:pPr marL="0" indent="0">
+              <a:lnSpc>
+                <a:spcPct val="114999"/>
+              </a:lnSpc>
+              <a:spcBef>
+                <a:spcPts val="1200"/>
+              </a:spcBef>
+              <a:buNone/>
+            </a:pPr>
+            <a:r>
+              <a:rPr lang="en-GB" sz="1700" dirty="0">
+                <a:solidFill>
+                  <a:srgbClr val="666666"/>
+                </a:solidFill>
+                <a:latin typeface="Source Code Pro"/>
+                <a:ea typeface="Source Code Pro"/>
+              </a:rPr>
+              <a:t>&lt;|</a:t>
+            </a:r>
+            <a:r>
+              <a:rPr lang="en-GB" sz="1700" dirty="0" err="1">
+                <a:solidFill>
+                  <a:srgbClr val="666666"/>
+                </a:solidFill>
+                <a:latin typeface="Source Code Pro"/>
+                <a:ea typeface="Source Code Pro"/>
+              </a:rPr>
+              <a:t>start_header_id</a:t>
+            </a:r>
+            <a:r>
+              <a:rPr lang="en-GB" sz="1700" dirty="0">
+                <a:solidFill>
+                  <a:srgbClr val="666666"/>
+                </a:solidFill>
+                <a:latin typeface="Source Code Pro"/>
+                <a:ea typeface="Source Code Pro"/>
+              </a:rPr>
+              <a:t>|&gt;</a:t>
+            </a:r>
+            <a:r>
+              <a:rPr lang="en-GB" sz="1700" dirty="0">
+                <a:solidFill>
+                  <a:srgbClr val="0B7743"/>
+                </a:solidFill>
+                <a:latin typeface="Source Code Pro"/>
+                <a:ea typeface="Source Code Pro"/>
+              </a:rPr>
+              <a:t>assistant</a:t>
+            </a:r>
+            <a:r>
+              <a:rPr lang="en-GB" sz="1700" dirty="0">
+                <a:solidFill>
+                  <a:srgbClr val="666666"/>
+                </a:solidFill>
+                <a:latin typeface="Source Code Pro"/>
+                <a:ea typeface="Source Code Pro"/>
+              </a:rPr>
+              <a:t>&lt;|</a:t>
+            </a:r>
+            <a:r>
+              <a:rPr lang="en-GB" sz="1700" dirty="0" err="1">
+                <a:solidFill>
+                  <a:srgbClr val="666666"/>
+                </a:solidFill>
+                <a:latin typeface="Source Code Pro"/>
+                <a:ea typeface="Source Code Pro"/>
+              </a:rPr>
+              <a:t>end_header_id</a:t>
+            </a:r>
+            <a:r>
+              <a:rPr lang="en-GB" sz="1700" dirty="0">
+                <a:solidFill>
+                  <a:srgbClr val="666666"/>
+                </a:solidFill>
+                <a:latin typeface="Source Code Pro"/>
+                <a:ea typeface="Source Code Pro"/>
+              </a:rPr>
+              <a:t>|&gt;</a:t>
+            </a:r>
+            <a:endParaRPr lang="en-US" sz="1700" dirty="0">
+              <a:solidFill>
+                <a:srgbClr val="00FDC8"/>
+              </a:solidFill>
+              <a:latin typeface="Source Code Pro"/>
+              <a:ea typeface="Source Code Pro"/>
+            </a:endParaRPr>
+          </a:p>
+          <a:p>
+            <a:pPr marL="0" indent="0">
+              <a:lnSpc>
+                <a:spcPct val="114999"/>
+              </a:lnSpc>
+              <a:spcBef>
+                <a:spcPts val="1200"/>
+              </a:spcBef>
+              <a:spcAft>
+                <a:spcPts val="1200"/>
+              </a:spcAft>
+              <a:buNone/>
+            </a:pPr>
+            <a:r>
+              <a:rPr lang="en-GB" sz="1700" dirty="0">
+                <a:solidFill>
+                  <a:srgbClr val="9325A5"/>
+                </a:solidFill>
+                <a:latin typeface="Source Code Pro"/>
+                <a:ea typeface="Source Code Pro"/>
+              </a:rPr>
+              <a:t>Certainly! Here is a recipe for macarons …</a:t>
+            </a:r>
+            <a:r>
+              <a:rPr lang="en-GB" sz="1700" dirty="0">
+                <a:solidFill>
+                  <a:srgbClr val="666666"/>
+                </a:solidFill>
+                <a:latin typeface="Source Code Pro"/>
+                <a:ea typeface="Source Code Pro"/>
+              </a:rPr>
+              <a:t>&lt;|</a:t>
+            </a:r>
+            <a:r>
+              <a:rPr lang="en-GB" sz="1700" dirty="0" err="1">
+                <a:solidFill>
+                  <a:srgbClr val="666666"/>
+                </a:solidFill>
+                <a:latin typeface="Source Code Pro"/>
+                <a:ea typeface="Source Code Pro"/>
+              </a:rPr>
+              <a:t>eot_id</a:t>
+            </a:r>
+            <a:r>
+              <a:rPr lang="en-GB" sz="1700" dirty="0">
+                <a:solidFill>
+                  <a:srgbClr val="666666"/>
+                </a:solidFill>
+                <a:latin typeface="Source Code Pro"/>
+                <a:ea typeface="Source Code Pro"/>
+              </a:rPr>
+              <a:t>|&gt;</a:t>
+            </a:r>
+            <a:endParaRPr lang="en-GB" dirty="0"/>
+          </a:p>
+          <a:p>
+            <a:pPr marL="0" indent="0">
+              <a:buNone/>
+            </a:pPr>
+            <a:endParaRPr lang="en-GB" sz="900" dirty="0">
+              <a:latin typeface="IBM Plex Mono"/>
+            </a:endParaRPr>
+          </a:p>
+          <a:p>
+            <a:pPr marL="0" indent="0">
+              <a:buNone/>
+            </a:pPr>
+            <a:endParaRPr lang="en-GB" sz="900" dirty="0">
+              <a:latin typeface="IBM Plex Mono"/>
+            </a:endParaRPr>
+          </a:p>
+        </p:txBody>
+      </p:sp>
+      <p:sp>
+        <p:nvSpPr>
+          <p:cNvPr id="14" name="TextBox 13">
+            <a:extLst>
+              <a:ext uri="{FF2B5EF4-FFF2-40B4-BE49-F238E27FC236}">
+                <a16:creationId xmlns:a16="http://schemas.microsoft.com/office/drawing/2014/main" id="{7254B9F3-FEB3-C32D-B278-29497148BAD8}"/>
+              </a:ext>
+            </a:extLst>
+          </p:cNvPr>
+          <p:cNvSpPr txBox="1"/>
+          <p:nvPr/>
+        </p:nvSpPr>
+        <p:spPr>
+          <a:xfrm>
+            <a:off x="8643696" y="3294302"/>
+            <a:ext cx="1123759" cy="523220"/>
+          </a:xfrm>
+          <a:prstGeom prst="rect">
+            <a:avLst/>
+          </a:prstGeom>
+          <a:noFill/>
+        </p:spPr>
+        <p:txBody>
+          <a:bodyPr rot="0" spcFirstLastPara="0" vertOverflow="overflow" horzOverflow="overflow" vert="horz" wrap="square" lIns="91440" tIns="45720" rIns="91440" bIns="45720" numCol="1" spcCol="0" rtlCol="0" fromWordArt="0" anchor="t" anchorCtr="0" forceAA="0" compatLnSpc="1">
+            <a:prstTxWarp prst="textNoShape">
+              <a:avLst/>
+            </a:prstTxWarp>
+            <a:spAutoFit/>
+          </a:bodyPr>
+          <a:lstStyle/>
+          <a:p>
+            <a:r>
+              <a:rPr lang="en-GB" sz="2800" b="1" dirty="0">
+                <a:solidFill>
+                  <a:schemeClr val="accent3"/>
+                </a:solidFill>
+                <a:latin typeface="IBM Plex Mono"/>
+              </a:rPr>
+              <a:t>role</a:t>
+            </a:r>
+            <a:endParaRPr lang="en-US">
+              <a:solidFill>
+                <a:schemeClr val="accent3"/>
+              </a:solidFill>
+            </a:endParaRPr>
+          </a:p>
+        </p:txBody>
+      </p:sp>
+      <p:sp>
+        <p:nvSpPr>
+          <p:cNvPr id="16" name="Oval 15">
+            <a:extLst>
+              <a:ext uri="{FF2B5EF4-FFF2-40B4-BE49-F238E27FC236}">
+                <a16:creationId xmlns:a16="http://schemas.microsoft.com/office/drawing/2014/main" id="{839153F8-4457-6BD2-0D36-0896EABC4121}"/>
+              </a:ext>
+            </a:extLst>
+          </p:cNvPr>
+          <p:cNvSpPr/>
+          <p:nvPr/>
+        </p:nvSpPr>
+        <p:spPr>
+          <a:xfrm>
+            <a:off x="5441757" y="1762606"/>
+            <a:ext cx="1062181" cy="592666"/>
+          </a:xfrm>
+          <a:custGeom>
+            <a:avLst/>
+            <a:gdLst>
+              <a:gd name="csX0" fmla="*/ 0 w 1062181"/>
+              <a:gd name="csY0" fmla="*/ 296333 h 592666"/>
+              <a:gd name="csX1" fmla="*/ 531091 w 1062181"/>
+              <a:gd name="csY1" fmla="*/ 0 h 592666"/>
+              <a:gd name="csX2" fmla="*/ 1062182 w 1062181"/>
+              <a:gd name="csY2" fmla="*/ 296333 h 592666"/>
+              <a:gd name="csX3" fmla="*/ 531091 w 1062181"/>
+              <a:gd name="csY3" fmla="*/ 592666 h 592666"/>
+              <a:gd name="csX4" fmla="*/ 0 w 1062181"/>
+              <a:gd name="csY4" fmla="*/ 296333 h 592666"/>
+            </a:gdLst>
+            <a:ahLst/>
+            <a:cxnLst>
+              <a:cxn ang="0">
+                <a:pos x="csX0" y="csY0"/>
+              </a:cxn>
+              <a:cxn ang="0">
+                <a:pos x="csX1" y="csY1"/>
+              </a:cxn>
+              <a:cxn ang="0">
+                <a:pos x="csX2" y="csY2"/>
+              </a:cxn>
+              <a:cxn ang="0">
+                <a:pos x="csX3" y="csY3"/>
+              </a:cxn>
+              <a:cxn ang="0">
+                <a:pos x="csX4" y="csY4"/>
+              </a:cxn>
+            </a:cxnLst>
+            <a:rect l="l" t="t" r="r" b="b"/>
+            <a:pathLst>
+              <a:path w="1062181" h="592666" extrusionOk="0">
+                <a:moveTo>
+                  <a:pt x="0" y="296333"/>
+                </a:moveTo>
+                <a:cubicBezTo>
+                  <a:pt x="-7844" y="108050"/>
+                  <a:pt x="217113" y="1779"/>
+                  <a:pt x="531091" y="0"/>
+                </a:cubicBezTo>
+                <a:cubicBezTo>
+                  <a:pt x="815437" y="12492"/>
+                  <a:pt x="1041465" y="110896"/>
+                  <a:pt x="1062182" y="296333"/>
+                </a:cubicBezTo>
+                <a:cubicBezTo>
+                  <a:pt x="1075449" y="482420"/>
+                  <a:pt x="835636" y="595693"/>
+                  <a:pt x="531091" y="592666"/>
+                </a:cubicBezTo>
+                <a:cubicBezTo>
+                  <a:pt x="207623" y="613596"/>
+                  <a:pt x="-19889" y="442097"/>
+                  <a:pt x="0" y="296333"/>
+                </a:cubicBezTo>
+                <a:close/>
+              </a:path>
+            </a:pathLst>
+          </a:custGeom>
+          <a:noFill/>
+          <a:ln>
+            <a:solidFill>
+              <a:schemeClr val="accent3"/>
+            </a:solidFill>
+            <a:extLst>
+              <a:ext uri="{C807C97D-BFC1-408E-A445-0C87EB9F89A2}">
+                <ask:lineSketchStyleProps xmlns:ask="http://schemas.microsoft.com/office/drawing/2018/sketchyshapes" sd="3499211612">
+                  <a:prstGeom prst="ellipse">
+                    <a:avLst/>
+                  </a:prstGeom>
+                  <ask:type>
+                    <ask:lineSketchScribble/>
+                  </ask:type>
+                </ask:lineSketchStyleProps>
+              </a:ext>
+            </a:extLst>
+          </a:ln>
+        </p:spPr>
+        <p:style>
+          <a:lnRef idx="2">
+            <a:schemeClr val="accent1">
+              <a:shade val="15000"/>
+            </a:schemeClr>
+          </a:lnRef>
+          <a:fillRef idx="1">
+            <a:schemeClr val="accent1"/>
+          </a:fillRef>
+          <a:effectRef idx="0">
+            <a:schemeClr val="accent1"/>
+          </a:effectRef>
+          <a:fontRef idx="minor">
+            <a:schemeClr val="lt1"/>
+          </a:fontRef>
+        </p:style>
+        <p:txBody>
+          <a:bodyPr rtlCol="0" anchor="ctr"/>
+          <a:lstStyle/>
+          <a:p>
+            <a:pPr algn="ctr"/>
+            <a:endParaRPr lang="en-GB"/>
+          </a:p>
+        </p:txBody>
+      </p:sp>
+      <p:sp>
+        <p:nvSpPr>
+          <p:cNvPr id="18" name="Oval 17">
+            <a:extLst>
+              <a:ext uri="{FF2B5EF4-FFF2-40B4-BE49-F238E27FC236}">
+                <a16:creationId xmlns:a16="http://schemas.microsoft.com/office/drawing/2014/main" id="{F1B94677-CD84-1383-C609-6BCE2E13C11B}"/>
+              </a:ext>
+            </a:extLst>
+          </p:cNvPr>
+          <p:cNvSpPr/>
+          <p:nvPr/>
+        </p:nvSpPr>
+        <p:spPr>
+          <a:xfrm>
+            <a:off x="3300460" y="3161914"/>
+            <a:ext cx="754303" cy="469515"/>
+          </a:xfrm>
+          <a:custGeom>
+            <a:avLst/>
+            <a:gdLst>
+              <a:gd name="csX0" fmla="*/ 0 w 754303"/>
+              <a:gd name="csY0" fmla="*/ 234758 h 469515"/>
+              <a:gd name="csX1" fmla="*/ 377152 w 754303"/>
+              <a:gd name="csY1" fmla="*/ 0 h 469515"/>
+              <a:gd name="csX2" fmla="*/ 754304 w 754303"/>
+              <a:gd name="csY2" fmla="*/ 234758 h 469515"/>
+              <a:gd name="csX3" fmla="*/ 377152 w 754303"/>
+              <a:gd name="csY3" fmla="*/ 469516 h 469515"/>
+              <a:gd name="csX4" fmla="*/ 0 w 754303"/>
+              <a:gd name="csY4" fmla="*/ 234758 h 469515"/>
+            </a:gdLst>
+            <a:ahLst/>
+            <a:cxnLst>
+              <a:cxn ang="0">
+                <a:pos x="csX0" y="csY0"/>
+              </a:cxn>
+              <a:cxn ang="0">
+                <a:pos x="csX1" y="csY1"/>
+              </a:cxn>
+              <a:cxn ang="0">
+                <a:pos x="csX2" y="csY2"/>
+              </a:cxn>
+              <a:cxn ang="0">
+                <a:pos x="csX3" y="csY3"/>
+              </a:cxn>
+              <a:cxn ang="0">
+                <a:pos x="csX4" y="csY4"/>
+              </a:cxn>
+            </a:cxnLst>
+            <a:rect l="l" t="t" r="r" b="b"/>
+            <a:pathLst>
+              <a:path w="754303" h="469515" extrusionOk="0">
+                <a:moveTo>
+                  <a:pt x="0" y="234758"/>
+                </a:moveTo>
+                <a:cubicBezTo>
+                  <a:pt x="-16189" y="54286"/>
+                  <a:pt x="110711" y="5007"/>
+                  <a:pt x="377152" y="0"/>
+                </a:cubicBezTo>
+                <a:cubicBezTo>
+                  <a:pt x="575281" y="14162"/>
+                  <a:pt x="734498" y="84286"/>
+                  <a:pt x="754304" y="234758"/>
+                </a:cubicBezTo>
+                <a:cubicBezTo>
+                  <a:pt x="778862" y="405924"/>
+                  <a:pt x="620370" y="478929"/>
+                  <a:pt x="377152" y="469516"/>
+                </a:cubicBezTo>
+                <a:cubicBezTo>
+                  <a:pt x="154922" y="479188"/>
+                  <a:pt x="-24728" y="342161"/>
+                  <a:pt x="0" y="234758"/>
+                </a:cubicBezTo>
+                <a:close/>
+              </a:path>
+            </a:pathLst>
+          </a:custGeom>
+          <a:noFill/>
+          <a:ln>
+            <a:solidFill>
+              <a:schemeClr val="accent3"/>
+            </a:solidFill>
+            <a:extLst>
+              <a:ext uri="{C807C97D-BFC1-408E-A445-0C87EB9F89A2}">
+                <ask:lineSketchStyleProps xmlns:ask="http://schemas.microsoft.com/office/drawing/2018/sketchyshapes" sd="3499211612">
+                  <a:prstGeom prst="ellipse">
+                    <a:avLst/>
+                  </a:prstGeom>
+                  <ask:type>
+                    <ask:lineSketchScribble/>
+                  </ask:type>
+                </ask:lineSketchStyleProps>
+              </a:ext>
+            </a:extLst>
+          </a:ln>
+        </p:spPr>
+        <p:style>
+          <a:lnRef idx="2">
+            <a:schemeClr val="accent1">
+              <a:shade val="15000"/>
+            </a:schemeClr>
+          </a:lnRef>
+          <a:fillRef idx="1">
+            <a:schemeClr val="accent1"/>
+          </a:fillRef>
+          <a:effectRef idx="0">
+            <a:schemeClr val="accent1"/>
+          </a:effectRef>
+          <a:fontRef idx="minor">
+            <a:schemeClr val="lt1"/>
+          </a:fontRef>
+        </p:style>
+        <p:txBody>
+          <a:bodyPr rtlCol="0" anchor="ctr"/>
+          <a:lstStyle/>
+          <a:p>
+            <a:pPr algn="ctr"/>
+            <a:endParaRPr lang="en-GB"/>
+          </a:p>
+        </p:txBody>
+      </p:sp>
+      <p:sp>
+        <p:nvSpPr>
+          <p:cNvPr id="20" name="Oval 19">
+            <a:extLst>
+              <a:ext uri="{FF2B5EF4-FFF2-40B4-BE49-F238E27FC236}">
+                <a16:creationId xmlns:a16="http://schemas.microsoft.com/office/drawing/2014/main" id="{8807FB0B-1F99-27E8-0C2A-383CEA095050}"/>
+              </a:ext>
+            </a:extLst>
+          </p:cNvPr>
+          <p:cNvSpPr/>
+          <p:nvPr/>
+        </p:nvSpPr>
+        <p:spPr>
+          <a:xfrm>
+            <a:off x="3300460" y="4408824"/>
+            <a:ext cx="1293090" cy="592666"/>
+          </a:xfrm>
+          <a:custGeom>
+            <a:avLst/>
+            <a:gdLst>
+              <a:gd name="csX0" fmla="*/ 0 w 1293090"/>
+              <a:gd name="csY0" fmla="*/ 296333 h 592666"/>
+              <a:gd name="csX1" fmla="*/ 646545 w 1293090"/>
+              <a:gd name="csY1" fmla="*/ 0 h 592666"/>
+              <a:gd name="csX2" fmla="*/ 1293090 w 1293090"/>
+              <a:gd name="csY2" fmla="*/ 296333 h 592666"/>
+              <a:gd name="csX3" fmla="*/ 646545 w 1293090"/>
+              <a:gd name="csY3" fmla="*/ 592666 h 592666"/>
+              <a:gd name="csX4" fmla="*/ 0 w 1293090"/>
+              <a:gd name="csY4" fmla="*/ 296333 h 592666"/>
+            </a:gdLst>
+            <a:ahLst/>
+            <a:cxnLst>
+              <a:cxn ang="0">
+                <a:pos x="csX0" y="csY0"/>
+              </a:cxn>
+              <a:cxn ang="0">
+                <a:pos x="csX1" y="csY1"/>
+              </a:cxn>
+              <a:cxn ang="0">
+                <a:pos x="csX2" y="csY2"/>
+              </a:cxn>
+              <a:cxn ang="0">
+                <a:pos x="csX3" y="csY3"/>
+              </a:cxn>
+              <a:cxn ang="0">
+                <a:pos x="csX4" y="csY4"/>
+              </a:cxn>
+            </a:cxnLst>
+            <a:rect l="l" t="t" r="r" b="b"/>
+            <a:pathLst>
+              <a:path w="1293090" h="592666" extrusionOk="0">
+                <a:moveTo>
+                  <a:pt x="0" y="296333"/>
+                </a:moveTo>
+                <a:cubicBezTo>
+                  <a:pt x="-5973" y="113924"/>
+                  <a:pt x="267849" y="1861"/>
+                  <a:pt x="646545" y="0"/>
+                </a:cubicBezTo>
+                <a:cubicBezTo>
+                  <a:pt x="994655" y="12492"/>
+                  <a:pt x="1272373" y="110896"/>
+                  <a:pt x="1293090" y="296333"/>
+                </a:cubicBezTo>
+                <a:cubicBezTo>
+                  <a:pt x="1313348" y="494238"/>
+                  <a:pt x="1011811" y="594873"/>
+                  <a:pt x="646545" y="592666"/>
+                </a:cubicBezTo>
+                <a:cubicBezTo>
+                  <a:pt x="259313" y="613596"/>
+                  <a:pt x="-19889" y="442097"/>
+                  <a:pt x="0" y="296333"/>
+                </a:cubicBezTo>
+                <a:close/>
+              </a:path>
+            </a:pathLst>
+          </a:custGeom>
+          <a:noFill/>
+          <a:ln>
+            <a:solidFill>
+              <a:schemeClr val="accent3"/>
+            </a:solidFill>
+            <a:extLst>
+              <a:ext uri="{C807C97D-BFC1-408E-A445-0C87EB9F89A2}">
+                <ask:lineSketchStyleProps xmlns:ask="http://schemas.microsoft.com/office/drawing/2018/sketchyshapes" sd="3499211612">
+                  <a:prstGeom prst="ellipse">
+                    <a:avLst/>
+                  </a:prstGeom>
+                  <ask:type>
+                    <ask:lineSketchScribble/>
+                  </ask:type>
+                </ask:lineSketchStyleProps>
+              </a:ext>
+            </a:extLst>
+          </a:ln>
+        </p:spPr>
+        <p:style>
+          <a:lnRef idx="2">
+            <a:schemeClr val="accent1">
+              <a:shade val="15000"/>
+            </a:schemeClr>
+          </a:lnRef>
+          <a:fillRef idx="1">
+            <a:schemeClr val="accent1"/>
+          </a:fillRef>
+          <a:effectRef idx="0">
+            <a:schemeClr val="accent1"/>
+          </a:effectRef>
+          <a:fontRef idx="minor">
+            <a:schemeClr val="lt1"/>
+          </a:fontRef>
+        </p:style>
+        <p:txBody>
+          <a:bodyPr rtlCol="0" anchor="ctr"/>
+          <a:lstStyle/>
+          <a:p>
+            <a:pPr algn="ctr"/>
+            <a:endParaRPr lang="en-GB"/>
+          </a:p>
+        </p:txBody>
+      </p:sp>
+    </p:spTree>
+    <p:extLst>
+      <p:ext uri="{BB962C8B-B14F-4D97-AF65-F5344CB8AC3E}">
+        <p14:creationId xmlns:p14="http://schemas.microsoft.com/office/powerpoint/2010/main" val="1287061977"/>
+      </p:ext>
+    </p:extLst>
+  </p:cSld>
+  <p:clrMapOvr>
+    <a:masterClrMapping/>
+  </p:clrMapOvr>
+  <p:timing>
+    <p:tnLst>
+      <p:par>
+        <p:cTn id="1" dur="indefinite" restart="never" nodeType="tmRoot">
+          <p:childTnLst>
+            <p:seq concurrent="1" nextAc="seek">
+              <p:cTn id="2" dur="indefinite" nodeType="mainSeq">
+                <p:childTnLst>
+                  <p:par>
+                    <p:cTn id="3" fill="hold">
+                      <p:stCondLst>
+                        <p:cond delay="indefinite"/>
+                      </p:stCondLst>
+                      <p:childTnLst>
+                        <p:par>
+                          <p:cTn id="4" fill="hold">
+                            <p:stCondLst>
+                              <p:cond delay="0"/>
+                            </p:stCondLst>
+                            <p:childTnLst>
+                              <p:par>
+                                <p:cTn id="5" presetID="1" presetClass="entr" presetSubtype="0" fill="hold" grpId="0" nodeType="clickEffect">
+                                  <p:stCondLst>
+                                    <p:cond delay="0"/>
+                                  </p:stCondLst>
+                                  <p:childTnLst>
+                                    <p:set>
+                                      <p:cBhvr>
+                                        <p:cTn id="6" dur="1" fill="hold">
+                                          <p:stCondLst>
+                                            <p:cond delay="0"/>
+                                          </p:stCondLst>
+                                        </p:cTn>
+                                        <p:tgtEl>
+                                          <p:spTgt spid="14"/>
+                                        </p:tgtEl>
+                                        <p:attrNameLst>
+                                          <p:attrName>style.visibility</p:attrName>
+                                        </p:attrNameLst>
+                                      </p:cBhvr>
+                                      <p:to>
+                                        <p:strVal val="visible"/>
+                                      </p:to>
+                                    </p:set>
+                                  </p:childTnLst>
+                                </p:cTn>
+                              </p:par>
+                              <p:par>
+                                <p:cTn id="7" presetID="1" presetClass="entr" presetSubtype="0" fill="hold" grpId="0" nodeType="withEffect">
+                                  <p:stCondLst>
+                                    <p:cond delay="0"/>
+                                  </p:stCondLst>
+                                  <p:childTnLst>
+                                    <p:set>
+                                      <p:cBhvr>
+                                        <p:cTn id="8" dur="1" fill="hold">
+                                          <p:stCondLst>
+                                            <p:cond delay="0"/>
+                                          </p:stCondLst>
+                                        </p:cTn>
+                                        <p:tgtEl>
+                                          <p:spTgt spid="16"/>
+                                        </p:tgtEl>
+                                        <p:attrNameLst>
+                                          <p:attrName>style.visibility</p:attrName>
+                                        </p:attrNameLst>
+                                      </p:cBhvr>
+                                      <p:to>
+                                        <p:strVal val="visible"/>
+                                      </p:to>
+                                    </p:set>
+                                  </p:childTnLst>
+                                </p:cTn>
+                              </p:par>
+                              <p:par>
+                                <p:cTn id="9" presetID="1" presetClass="entr" presetSubtype="0" fill="hold" grpId="0" nodeType="withEffect">
+                                  <p:stCondLst>
+                                    <p:cond delay="0"/>
+                                  </p:stCondLst>
+                                  <p:childTnLst>
+                                    <p:set>
+                                      <p:cBhvr>
+                                        <p:cTn id="10" dur="1" fill="hold">
+                                          <p:stCondLst>
+                                            <p:cond delay="0"/>
+                                          </p:stCondLst>
+                                        </p:cTn>
+                                        <p:tgtEl>
+                                          <p:spTgt spid="18"/>
+                                        </p:tgtEl>
+                                        <p:attrNameLst>
+                                          <p:attrName>style.visibility</p:attrName>
+                                        </p:attrNameLst>
+                                      </p:cBhvr>
+                                      <p:to>
+                                        <p:strVal val="visible"/>
+                                      </p:to>
+                                    </p:set>
+                                  </p:childTnLst>
+                                </p:cTn>
+                              </p:par>
+                              <p:par>
+                                <p:cTn id="11" presetID="1" presetClass="entr" presetSubtype="0" fill="hold" grpId="0" nodeType="withEffect">
+                                  <p:stCondLst>
+                                    <p:cond delay="0"/>
+                                  </p:stCondLst>
+                                  <p:childTnLst>
+                                    <p:set>
+                                      <p:cBhvr>
+                                        <p:cTn id="12" dur="1" fill="hold">
+                                          <p:stCondLst>
+                                            <p:cond delay="0"/>
+                                          </p:stCondLst>
+                                        </p:cTn>
+                                        <p:tgtEl>
+                                          <p:spTgt spid="20"/>
+                                        </p:tgtEl>
+                                        <p:attrNameLst>
+                                          <p:attrName>style.visibility</p:attrName>
+                                        </p:attrNameLst>
+                                      </p:cBhvr>
+                                      <p:to>
+                                        <p:strVal val="visible"/>
+                                      </p:to>
+                                    </p:set>
+                                  </p:childTnLst>
+                                </p:cTn>
+                              </p:par>
+                            </p:childTnLst>
+                          </p:cTn>
+                        </p:par>
+                      </p:childTnLst>
+                    </p:cTn>
+                  </p:par>
+                </p:childTnLst>
+              </p:cTn>
+              <p:prevCondLst>
+                <p:cond evt="onPrev" delay="0">
+                  <p:tgtEl>
+                    <p:sldTgt/>
+                  </p:tgtEl>
+                </p:cond>
+              </p:prevCondLst>
+              <p:nextCondLst>
+                <p:cond evt="onNext" delay="0">
+                  <p:tgtEl>
+                    <p:sldTgt/>
+                  </p:tgtEl>
+                </p:cond>
+              </p:nextCondLst>
+            </p:seq>
+          </p:childTnLst>
+        </p:cTn>
+      </p:par>
+    </p:tnLst>
+    <p:bldLst>
+      <p:bldP spid="14" grpId="0"/>
+      <p:bldP spid="16" grpId="0" animBg="1"/>
+      <p:bldP spid="18" grpId="0" animBg="1"/>
+      <p:bldP spid="20" grpId="0" animBg="1"/>
     </p:bldLst>
   </p:timing>
 </p:sld>

</xml_diff>

<commit_message>
chore(slides): add timings to fine-tuning slides
</commit_message>
<xml_diff>
--- a/slides/7-finetuning.pptx
+++ b/slides/7-finetuning.pptx
@@ -1657,6 +1657,62 @@
           <a:p>
             <a:r>
               <a:rPr lang="en-US" dirty="0"/>
+              <a:t>[TIMINGS]</a:t>
+            </a:r>
+          </a:p>
+          <a:p>
+            <a:endParaRPr lang="en-US" dirty="0"/>
+          </a:p>
+          <a:p>
+            <a:r>
+              <a:rPr lang="en-US" dirty="0"/>
+              <a:t>Practice: 25m</a:t>
+            </a:r>
+          </a:p>
+          <a:p>
+            <a:r>
+              <a:rPr lang="en-US" dirty="0"/>
+              <a:t>Target</a:t>
+            </a:r>
+            <a:r>
+              <a:rPr lang="en-US"/>
+              <a:t>: 30m</a:t>
+            </a:r>
+            <a:endParaRPr lang="en-US" dirty="0"/>
+          </a:p>
+          <a:p>
+            <a:endParaRPr lang="en-US" dirty="0"/>
+          </a:p>
+          <a:p>
+            <a:r>
+              <a:rPr lang="en-US" dirty="0"/>
+              <a:t>Start time: 16:00</a:t>
+            </a:r>
+          </a:p>
+          <a:p>
+            <a:r>
+              <a:rPr lang="en-US" dirty="0"/>
+              <a:t>End time: 17:00</a:t>
+            </a:r>
+          </a:p>
+          <a:p>
+            <a:endParaRPr lang="en-US" dirty="0"/>
+          </a:p>
+          <a:p>
+            <a:r>
+              <a:rPr lang="en-US" dirty="0"/>
+              <a:t>---</a:t>
+            </a:r>
+          </a:p>
+          <a:p>
+            <a:endParaRPr lang="en-US" dirty="0"/>
+          </a:p>
+          <a:p>
+            <a:endParaRPr lang="en-US" dirty="0"/>
+          </a:p>
+          <a:p>
+            <a:r>
+              <a:rPr lang="en-US" dirty="0"/>
               <a:t>Deepseek-R1 matched </a:t>
             </a:r>
             <a:r>
@@ -12118,12 +12174,6 @@
           <a:p>
             <a:r>
               <a:rPr lang="en-GB" dirty="0"/>
-              <a:t>Why?</a:t>
-            </a:r>
-          </a:p>
-          <a:p>
-            <a:r>
-              <a:rPr lang="en-GB" dirty="0"/>
               <a:t>Post-training vs. Fine-tuning</a:t>
             </a:r>
           </a:p>
@@ -12139,10 +12189,9 @@
               <a:rPr lang="en-GB" dirty="0" err="1"/>
               <a:t>LoRA</a:t>
             </a:r>
-            <a:r>
-              <a:rPr lang="en-GB" dirty="0"/>
-              <a:t> and </a:t>
-            </a:r>
+            <a:endParaRPr lang="en-GB" dirty="0"/>
+          </a:p>
+          <a:p>
             <a:r>
               <a:rPr lang="en-GB" dirty="0" err="1"/>
               <a:t>qLoRA</a:t>

</xml_diff>